<commit_message>
Replace paper with Overleaf revision: simpler English, cleaner structure
Major user revision uploaded from Overleaf:
- Abstract rewritten in plainer academic English
- Introduction streamlined; "Introduction and Motivation" header
- RQ1-RQ5 explicit list replaced with three prose questions
- Related Work and Background merged + condensed (one paragraph
  per related system instead of multi-sentence comparisons)
- Implementation Details promoted to Section 4 (before Experiments)
- Experiments split: Section 5 (setup + main results) and Section 6
  (Analysis, Ablations, and Findings)
- Inline filecontents block removed; references.bib used directly
- Page count 15 -> 10 (mostly from removed RQ list, condensed Related
  Work, and tighter prose throughout)

Also drop now-redundant references_corrected.bib (already merged into
references.bib).

Co-Authored-By: Claude Opus 4.7 (1M context) <noreply@anthropic.com>
</commit_message>
<xml_diff>
--- a/RAGCachePP_Presentation.pptx
+++ b/RAGCachePP_Presentation.pptx
@@ -4,25 +4,28 @@
   <p:sldMasterIdLst>
     <p:sldMasterId id="2147483648" r:id="rId1"/>
   </p:sldMasterIdLst>
+  <p:notesMasterIdLst>
+    <p:notesMasterId r:id="rId18"/>
+  </p:notesMasterIdLst>
   <p:sldIdLst>
-    <p:sldId id="256" r:id="rId7"/>
-    <p:sldId id="257" r:id="rId9"/>
-    <p:sldId id="258" r:id="rId10"/>
-    <p:sldId id="259" r:id="rId11"/>
-    <p:sldId id="260" r:id="rId12"/>
-    <p:sldId id="261" r:id="rId13"/>
-    <p:sldId id="262" r:id="rId14"/>
-    <p:sldId id="263" r:id="rId15"/>
-    <p:sldId id="264" r:id="rId16"/>
-    <p:sldId id="265" r:id="rId17"/>
-    <p:sldId id="266" r:id="rId18"/>
-    <p:sldId id="267" r:id="rId19"/>
-    <p:sldId id="268" r:id="rId20"/>
-    <p:sldId id="269" r:id="rId21"/>
-    <p:sldId id="270" r:id="rId22"/>
-    <p:sldId id="271" r:id="rId23"/>
+    <p:sldId id="256" r:id="rId2"/>
+    <p:sldId id="257" r:id="rId3"/>
+    <p:sldId id="258" r:id="rId4"/>
+    <p:sldId id="259" r:id="rId5"/>
+    <p:sldId id="260" r:id="rId6"/>
+    <p:sldId id="261" r:id="rId7"/>
+    <p:sldId id="262" r:id="rId8"/>
+    <p:sldId id="263" r:id="rId9"/>
+    <p:sldId id="264" r:id="rId10"/>
+    <p:sldId id="265" r:id="rId11"/>
+    <p:sldId id="266" r:id="rId12"/>
+    <p:sldId id="267" r:id="rId13"/>
+    <p:sldId id="268" r:id="rId14"/>
+    <p:sldId id="269" r:id="rId15"/>
+    <p:sldId id="270" r:id="rId16"/>
+    <p:sldId id="271" r:id="rId17"/>
   </p:sldIdLst>
-  <p:sldSz cx="12191695" cy="6858000" type="screen4x3"/>
+  <p:sldSz cx="12192000" cy="6858000"/>
   <p:notesSz cx="6858000" cy="9144000"/>
   <p:defaultTextStyle>
     <a:defPPr>
@@ -119,11 +122,27 @@
       </a:defRPr>
     </a:lvl9pPr>
   </p:defaultTextStyle>
+  <p:extLst>
+    <p:ext uri="{EFAFB233-063F-42B5-8137-9DF3F51BA10A}">
+      <p15:sldGuideLst xmlns:p15="http://schemas.microsoft.com/office/powerpoint/2012/main">
+        <p15:guide id="1" orient="horz" pos="2160">
+          <p15:clr>
+            <a:srgbClr val="A4A3A4"/>
+          </p15:clr>
+        </p15:guide>
+        <p15:guide id="2" pos="2880">
+          <p15:clr>
+            <a:srgbClr val="A4A3A4"/>
+          </p15:clr>
+        </p15:guide>
+      </p15:sldGuideLst>
+    </p:ext>
+  </p:extLst>
 </p:presentation>
 </file>
 
 <file path=ppt/notesMasters/notesMaster1.xml><?xml version="1.0" encoding="utf-8"?>
-<p:notesMaster xmlns:a="http://schemas.openxmlformats.org/drawingml/2006/main" xmlns:p="http://schemas.openxmlformats.org/presentationml/2006/main" xmlns:r="http://schemas.openxmlformats.org/officeDocument/2006/relationships">
+<p:notesMaster xmlns:a="http://schemas.openxmlformats.org/drawingml/2006/main" xmlns:r="http://schemas.openxmlformats.org/officeDocument/2006/relationships" xmlns:p="http://schemas.openxmlformats.org/presentationml/2006/main">
   <p:cSld>
     <p:bg>
       <p:bgRef idx="1001">
@@ -144,241 +163,16 @@
           <a:chExt cx="0" cy="0"/>
         </a:xfrm>
       </p:grpSpPr>
-      <p:sp>
-        <p:nvSpPr>
-          <p:cNvPr id="2" name="Header Placeholder 1"/>
-          <p:cNvSpPr>
-            <a:spLocks noGrp="1"/>
-          </p:cNvSpPr>
-          <p:nvPr>
-            <p:ph type="hdr" sz="quarter"/>
-          </p:nvPr>
-        </p:nvSpPr>
-        <p:spPr>
-          <a:xfrm>
-            <a:off x="0" y="0"/>
-            <a:ext cx="2971800" cy="457200"/>
-          </a:xfrm>
-          <a:prstGeom prst="rect">
-            <a:avLst/>
-          </a:prstGeom>
-        </p:spPr>
-        <p:txBody>
-          <a:bodyPr vert="horz" lIns="91440" tIns="45720" rIns="91440" bIns="45720" rtlCol="0"/>
-          <a:lstStyle>
-            <a:lvl1pPr algn="l">
-              <a:defRPr sz="1200"/>
-            </a:lvl1pPr>
-          </a:lstStyle>
-          <a:p>
-            <a:endParaRPr lang="en-US"/>
-          </a:p>
-        </p:txBody>
-      </p:sp>
-      <p:sp>
-        <p:nvSpPr>
-          <p:cNvPr id="3" name="Date Placeholder 2"/>
-          <p:cNvSpPr>
-            <a:spLocks noGrp="1"/>
-          </p:cNvSpPr>
-          <p:nvPr>
-            <p:ph type="dt" idx="1"/>
-          </p:nvPr>
-        </p:nvSpPr>
-        <p:spPr>
-          <a:xfrm>
-            <a:off x="3884613" y="0"/>
-            <a:ext cx="2971800" cy="457200"/>
-          </a:xfrm>
-          <a:prstGeom prst="rect">
-            <a:avLst/>
-          </a:prstGeom>
-        </p:spPr>
-        <p:txBody>
-          <a:bodyPr vert="horz" lIns="91440" tIns="45720" rIns="91440" bIns="45720" rtlCol="0"/>
-          <a:lstStyle>
-            <a:lvl1pPr algn="r">
-              <a:defRPr sz="1200"/>
-            </a:lvl1pPr>
-          </a:lstStyle>
-          <a:p>
-            <a:fld id="{0F89C1C7-3DCD-1040-A9CF-14679D8B5DDD}" type="datetimeFigureOut">
-              <a:rPr lang="en-US" smtClean="0"/>
-              <a:t>10/17/16</a:t>
-            </a:fld>
-            <a:endParaRPr lang="en-US"/>
-          </a:p>
-        </p:txBody>
-      </p:sp>
-      <p:sp>
-        <p:nvSpPr>
-          <p:cNvPr id="4" name="Slide Image Placeholder 3"/>
-          <p:cNvSpPr>
-            <a:spLocks noGrp="1" noRot="1" noChangeAspect="1"/>
-          </p:cNvSpPr>
-          <p:nvPr>
-            <p:ph type="sldImg" idx="2"/>
-          </p:nvPr>
-        </p:nvSpPr>
-        <p:spPr>
-          <a:xfrm>
-            <a:off x="1143000" y="685800"/>
-            <a:ext cx="4572000" cy="3429000"/>
-          </a:xfrm>
-          <a:prstGeom prst="rect">
-            <a:avLst/>
-          </a:prstGeom>
-          <a:noFill/>
-          <a:ln w="12700">
-            <a:solidFill>
-              <a:prstClr val="black"/>
-            </a:solidFill>
-          </a:ln>
-        </p:spPr>
-        <p:txBody>
-          <a:bodyPr vert="horz" lIns="91440" tIns="45720" rIns="91440" bIns="45720" rtlCol="0" anchor="ctr"/>
-          <a:lstStyle/>
-          <a:p>
-            <a:endParaRPr lang="en-US"/>
-          </a:p>
-        </p:txBody>
-      </p:sp>
-      <p:sp>
-        <p:nvSpPr>
-          <p:cNvPr id="5" name="Notes Placeholder 4"/>
-          <p:cNvSpPr>
-            <a:spLocks noGrp="1"/>
-          </p:cNvSpPr>
-          <p:nvPr>
-            <p:ph type="body" sz="quarter" idx="3"/>
-          </p:nvPr>
-        </p:nvSpPr>
-        <p:spPr>
-          <a:xfrm>
-            <a:off x="685800" y="4343400"/>
-            <a:ext cx="5486400" cy="4114800"/>
-          </a:xfrm>
-          <a:prstGeom prst="rect">
-            <a:avLst/>
-          </a:prstGeom>
-        </p:spPr>
-        <p:txBody>
-          <a:bodyPr vert="horz" lIns="91440" tIns="45720" rIns="91440" bIns="45720" rtlCol="0"/>
-          <a:lstStyle/>
-          <a:p>
-            <a:pPr lvl="0"/>
-            <a:r>
-              <a:rPr lang="en-US" smtClean="0"/>
-              <a:t>Click to edit Master text styles</a:t>
-            </a:r>
-          </a:p>
-          <a:p>
-            <a:pPr lvl="1"/>
-            <a:r>
-              <a:rPr lang="en-US" smtClean="0"/>
-              <a:t>Second level</a:t>
-            </a:r>
-          </a:p>
-          <a:p>
-            <a:pPr lvl="2"/>
-            <a:r>
-              <a:rPr lang="en-US" smtClean="0"/>
-              <a:t>Third level</a:t>
-            </a:r>
-          </a:p>
-          <a:p>
-            <a:pPr lvl="3"/>
-            <a:r>
-              <a:rPr lang="en-US" smtClean="0"/>
-              <a:t>Fourth level</a:t>
-            </a:r>
-          </a:p>
-          <a:p>
-            <a:pPr lvl="4"/>
-            <a:r>
-              <a:rPr lang="en-US" smtClean="0"/>
-              <a:t>Fifth level</a:t>
-            </a:r>
-            <a:endParaRPr lang="en-US"/>
-          </a:p>
-        </p:txBody>
-      </p:sp>
-      <p:sp>
-        <p:nvSpPr>
-          <p:cNvPr id="6" name="Footer Placeholder 5"/>
-          <p:cNvSpPr>
-            <a:spLocks noGrp="1"/>
-          </p:cNvSpPr>
-          <p:nvPr>
-            <p:ph type="ftr" sz="quarter" idx="4"/>
-          </p:nvPr>
-        </p:nvSpPr>
-        <p:spPr>
-          <a:xfrm>
-            <a:off x="0" y="8685213"/>
-            <a:ext cx="2971800" cy="457200"/>
-          </a:xfrm>
-          <a:prstGeom prst="rect">
-            <a:avLst/>
-          </a:prstGeom>
-        </p:spPr>
-        <p:txBody>
-          <a:bodyPr vert="horz" lIns="91440" tIns="45720" rIns="91440" bIns="45720" rtlCol="0" anchor="b"/>
-          <a:lstStyle>
-            <a:lvl1pPr algn="l">
-              <a:defRPr sz="1200"/>
-            </a:lvl1pPr>
-          </a:lstStyle>
-          <a:p>
-            <a:endParaRPr lang="en-US"/>
-          </a:p>
-        </p:txBody>
-      </p:sp>
-      <p:sp>
-        <p:nvSpPr>
-          <p:cNvPr id="7" name="Slide Number Placeholder 6"/>
-          <p:cNvSpPr>
-            <a:spLocks noGrp="1"/>
-          </p:cNvSpPr>
-          <p:nvPr>
-            <p:ph type="sldNum" sz="quarter" idx="5"/>
-          </p:nvPr>
-        </p:nvSpPr>
-        <p:spPr>
-          <a:xfrm>
-            <a:off x="3884613" y="8685213"/>
-            <a:ext cx="2971800" cy="457200"/>
-          </a:xfrm>
-          <a:prstGeom prst="rect">
-            <a:avLst/>
-          </a:prstGeom>
-        </p:spPr>
-        <p:txBody>
-          <a:bodyPr vert="horz" lIns="91440" tIns="45720" rIns="91440" bIns="45720" rtlCol="0" anchor="b"/>
-          <a:lstStyle>
-            <a:lvl1pPr algn="r">
-              <a:defRPr sz="1200"/>
-            </a:lvl1pPr>
-          </a:lstStyle>
-          <a:p>
-            <a:fld id="{BB5E49A5-4136-284D-997B-48E1D791AD67}" type="slidenum">
-              <a:rPr lang="en-US" smtClean="0"/>
-              <a:t>‹#›</a:t>
-            </a:fld>
-            <a:endParaRPr lang="en-US"/>
-          </a:p>
-        </p:txBody>
-      </p:sp>
     </p:spTree>
     <p:extLst>
       <p:ext uri="{BB962C8B-B14F-4D97-AF65-F5344CB8AC3E}">
-        <p14:creationId xmlns:p14="http://schemas.microsoft.com/office/powerpoint/2010/main" val="2623252185"/>
+        <p14:creationId xmlns:p14="http://schemas.microsoft.com/office/powerpoint/2010/main" val="3227215733"/>
       </p:ext>
     </p:extLst>
   </p:cSld>
   <p:clrMap bg1="lt1" tx1="dk1" bg2="lt2" tx2="dk2" accent1="accent1" accent2="accent2" accent3="accent3" accent4="accent4" accent5="accent5" accent6="accent6" hlink="hlink" folHlink="folHlink"/>
   <p:notesStyle>
-    <a:lvl1pPr marL="0" algn="l" defTabSz="457200" rtl="0" eaLnBrk="1" latinLnBrk="0" hangingPunct="1">
+    <a:lvl1pPr marL="0" algn="l" defTabSz="914400" rtl="0" eaLnBrk="1" latinLnBrk="0" hangingPunct="1">
       <a:defRPr sz="1200" kern="1200">
         <a:solidFill>
           <a:schemeClr val="tx1"/>
@@ -388,7 +182,7 @@
         <a:cs typeface="+mn-cs"/>
       </a:defRPr>
     </a:lvl1pPr>
-    <a:lvl2pPr marL="457200" algn="l" defTabSz="457200" rtl="0" eaLnBrk="1" latinLnBrk="0" hangingPunct="1">
+    <a:lvl2pPr marL="457200" algn="l" defTabSz="914400" rtl="0" eaLnBrk="1" latinLnBrk="0" hangingPunct="1">
       <a:defRPr sz="1200" kern="1200">
         <a:solidFill>
           <a:schemeClr val="tx1"/>
@@ -398,7 +192,7 @@
         <a:cs typeface="+mn-cs"/>
       </a:defRPr>
     </a:lvl2pPr>
-    <a:lvl3pPr marL="914400" algn="l" defTabSz="457200" rtl="0" eaLnBrk="1" latinLnBrk="0" hangingPunct="1">
+    <a:lvl3pPr marL="914400" algn="l" defTabSz="914400" rtl="0" eaLnBrk="1" latinLnBrk="0" hangingPunct="1">
       <a:defRPr sz="1200" kern="1200">
         <a:solidFill>
           <a:schemeClr val="tx1"/>
@@ -408,7 +202,7 @@
         <a:cs typeface="+mn-cs"/>
       </a:defRPr>
     </a:lvl3pPr>
-    <a:lvl4pPr marL="1371600" algn="l" defTabSz="457200" rtl="0" eaLnBrk="1" latinLnBrk="0" hangingPunct="1">
+    <a:lvl4pPr marL="1371600" algn="l" defTabSz="914400" rtl="0" eaLnBrk="1" latinLnBrk="0" hangingPunct="1">
       <a:defRPr sz="1200" kern="1200">
         <a:solidFill>
           <a:schemeClr val="tx1"/>
@@ -418,7 +212,7 @@
         <a:cs typeface="+mn-cs"/>
       </a:defRPr>
     </a:lvl4pPr>
-    <a:lvl5pPr marL="1828800" algn="l" defTabSz="457200" rtl="0" eaLnBrk="1" latinLnBrk="0" hangingPunct="1">
+    <a:lvl5pPr marL="1828800" algn="l" defTabSz="914400" rtl="0" eaLnBrk="1" latinLnBrk="0" hangingPunct="1">
       <a:defRPr sz="1200" kern="1200">
         <a:solidFill>
           <a:schemeClr val="tx1"/>
@@ -428,7 +222,7 @@
         <a:cs typeface="+mn-cs"/>
       </a:defRPr>
     </a:lvl5pPr>
-    <a:lvl6pPr marL="2286000" algn="l" defTabSz="457200" rtl="0" eaLnBrk="1" latinLnBrk="0" hangingPunct="1">
+    <a:lvl6pPr marL="2286000" algn="l" defTabSz="914400" rtl="0" eaLnBrk="1" latinLnBrk="0" hangingPunct="1">
       <a:defRPr sz="1200" kern="1200">
         <a:solidFill>
           <a:schemeClr val="tx1"/>
@@ -438,7 +232,7 @@
         <a:cs typeface="+mn-cs"/>
       </a:defRPr>
     </a:lvl6pPr>
-    <a:lvl7pPr marL="2743200" algn="l" defTabSz="457200" rtl="0" eaLnBrk="1" latinLnBrk="0" hangingPunct="1">
+    <a:lvl7pPr marL="2743200" algn="l" defTabSz="914400" rtl="0" eaLnBrk="1" latinLnBrk="0" hangingPunct="1">
       <a:defRPr sz="1200" kern="1200">
         <a:solidFill>
           <a:schemeClr val="tx1"/>
@@ -448,7 +242,7 @@
         <a:cs typeface="+mn-cs"/>
       </a:defRPr>
     </a:lvl7pPr>
-    <a:lvl8pPr marL="3200400" algn="l" defTabSz="457200" rtl="0" eaLnBrk="1" latinLnBrk="0" hangingPunct="1">
+    <a:lvl8pPr marL="3200400" algn="l" defTabSz="914400" rtl="0" eaLnBrk="1" latinLnBrk="0" hangingPunct="1">
       <a:defRPr sz="1200" kern="1200">
         <a:solidFill>
           <a:schemeClr val="tx1"/>
@@ -458,7 +252,7 @@
         <a:cs typeface="+mn-cs"/>
       </a:defRPr>
     </a:lvl8pPr>
-    <a:lvl9pPr marL="3657600" algn="l" defTabSz="457200" rtl="0" eaLnBrk="1" latinLnBrk="0" hangingPunct="1">
+    <a:lvl9pPr marL="3657600" algn="l" defTabSz="914400" rtl="0" eaLnBrk="1" latinLnBrk="0" hangingPunct="1">
       <a:defRPr sz="1200" kern="1200">
         <a:solidFill>
           <a:schemeClr val="tx1"/>
@@ -473,7 +267,7 @@
 </file>
 
 <file path=ppt/notesSlides/notesSlide1.xml><?xml version="1.0" encoding="utf-8"?>
-<p:notes xmlns:a="http://schemas.openxmlformats.org/drawingml/2006/main" xmlns:p="http://schemas.openxmlformats.org/presentationml/2006/main" xmlns:r="http://schemas.openxmlformats.org/officeDocument/2006/relationships">
+<p:notes xmlns:a="http://schemas.openxmlformats.org/drawingml/2006/main" xmlns:r="http://schemas.openxmlformats.org/officeDocument/2006/relationships" xmlns:p="http://schemas.openxmlformats.org/presentationml/2006/main">
   <p:cSld>
     <p:spTree>
       <p:nvGrpSpPr>
@@ -493,7 +287,7 @@
         <p:nvSpPr>
           <p:cNvPr id="2" name="Slide Image Placeholder 1"/>
           <p:cNvSpPr>
-            <a:spLocks noGrp="1"/>
+            <a:spLocks noGrp="1" noRot="1" noChangeAspect="1"/>
           </p:cNvSpPr>
           <p:nvPr>
             <p:ph type="sldImg" idx="2"/>
@@ -508,7 +302,7 @@
             <a:spLocks noGrp="1"/>
           </p:cNvSpPr>
           <p:nvPr>
-            <p:ph type="body" idx="3" sz="quarter"/>
+            <p:ph type="body" sz="quarter" idx="3"/>
           </p:nvPr>
         </p:nvSpPr>
         <p:spPr/>
@@ -520,7 +314,9 @@
               <a:t>Good morning/afternoon, everyone. I'm Kaizhen Tan, and together with Rong Gu and Mingyuan Li, we'll present RAGCache++, a prompt-layer scheduling system that reduces LLM serving latency in RAG applications through intelligent document ordering.</a:t>
             </a:r>
           </a:p>
-          <a:p/>
+          <a:p>
+            <a:endParaRPr/>
+          </a:p>
           <a:p>
             <a:r>
               <a:t>Our system achieves 20 to 33 percent TTFT reduction, reaches 97.5% of oracle performance, and requires only about 150 lines of Python — with absolutely zero modifications to the serving engine.</a:t>
@@ -535,7 +331,7 @@
             <a:spLocks noGrp="1"/>
           </p:cNvSpPr>
           <p:nvPr>
-            <p:ph type="sldNum" idx="5" sz="quarter"/>
+            <p:ph type="sldNum" sz="quarter" idx="5"/>
           </p:nvPr>
         </p:nvSpPr>
         <p:spPr/>
@@ -549,7 +345,7 @@
 </file>
 
 <file path=ppt/notesSlides/notesSlide10.xml><?xml version="1.0" encoding="utf-8"?>
-<p:notes xmlns:a="http://schemas.openxmlformats.org/drawingml/2006/main" xmlns:p="http://schemas.openxmlformats.org/presentationml/2006/main" xmlns:r="http://schemas.openxmlformats.org/officeDocument/2006/relationships">
+<p:notes xmlns:a="http://schemas.openxmlformats.org/drawingml/2006/main" xmlns:r="http://schemas.openxmlformats.org/officeDocument/2006/relationships" xmlns:p="http://schemas.openxmlformats.org/presentationml/2006/main">
   <p:cSld>
     <p:spTree>
       <p:nvGrpSpPr>
@@ -569,7 +365,7 @@
         <p:nvSpPr>
           <p:cNvPr id="2" name="Slide Image Placeholder 1"/>
           <p:cNvSpPr>
-            <a:spLocks noGrp="1"/>
+            <a:spLocks noGrp="1" noRot="1" noChangeAspect="1"/>
           </p:cNvSpPr>
           <p:nvPr>
             <p:ph type="sldImg" idx="2"/>
@@ -584,7 +380,7 @@
             <a:spLocks noGrp="1"/>
           </p:cNvSpPr>
           <p:nvPr>
-            <p:ph type="body" idx="3" sz="quarter"/>
+            <p:ph type="body" sz="quarter" idx="3"/>
           </p:nvPr>
         </p:nvSpPr>
         <p:spPr/>
@@ -605,7 +401,7 @@
             <a:spLocks noGrp="1"/>
           </p:cNvSpPr>
           <p:nvPr>
-            <p:ph type="sldNum" idx="5" sz="quarter"/>
+            <p:ph type="sldNum" sz="quarter" idx="5"/>
           </p:nvPr>
         </p:nvSpPr>
         <p:spPr/>
@@ -619,7 +415,7 @@
 </file>
 
 <file path=ppt/notesSlides/notesSlide11.xml><?xml version="1.0" encoding="utf-8"?>
-<p:notes xmlns:a="http://schemas.openxmlformats.org/drawingml/2006/main" xmlns:p="http://schemas.openxmlformats.org/presentationml/2006/main" xmlns:r="http://schemas.openxmlformats.org/officeDocument/2006/relationships">
+<p:notes xmlns:a="http://schemas.openxmlformats.org/drawingml/2006/main" xmlns:r="http://schemas.openxmlformats.org/officeDocument/2006/relationships" xmlns:p="http://schemas.openxmlformats.org/presentationml/2006/main">
   <p:cSld>
     <p:spTree>
       <p:nvGrpSpPr>
@@ -639,7 +435,7 @@
         <p:nvSpPr>
           <p:cNvPr id="2" name="Slide Image Placeholder 1"/>
           <p:cNvSpPr>
-            <a:spLocks noGrp="1"/>
+            <a:spLocks noGrp="1" noRot="1" noChangeAspect="1"/>
           </p:cNvSpPr>
           <p:nvPr>
             <p:ph type="sldImg" idx="2"/>
@@ -654,7 +450,7 @@
             <a:spLocks noGrp="1"/>
           </p:cNvSpPr>
           <p:nvPr>
-            <p:ph type="body" idx="3" sz="quarter"/>
+            <p:ph type="body" sz="quarter" idx="3"/>
           </p:nvPr>
         </p:nvSpPr>
         <p:spPr/>
@@ -666,19 +462,25 @@
               <a:t>A natural concern is whether reordering degrades answer quality. Our evaluation confirms it does not.</a:t>
             </a:r>
           </a:p>
-          <a:p/>
+          <a:p>
+            <a:endParaRPr/>
+          </a:p>
           <a:p>
             <a:r>
               <a:t>On extractive QA with 100 questions using Qwen2.5-7B, both orderings achieve perfect exact match of 1.000. Delta EM equals zero — absolutely no degradation.</a:t>
             </a:r>
           </a:p>
-          <a:p/>
+          <a:p>
+            <a:endParaRPr/>
+          </a:p>
           <a:p>
             <a:r>
               <a:t>For multi-hop reasoning, which is a harder test — we used 40 two-hop examples where passage A contains "X is related to Y" and passage B contains "Y leads to Z." We tested four conditions: natural and reversed evidence order, crossed with retrieval and optimized document ordering.</a:t>
             </a:r>
           </a:p>
-          <a:p/>
+          <a:p>
+            <a:endParaRPr/>
+          </a:p>
           <a:p>
             <a:r>
               <a:t>Two findings: first, evidence order matters — natural ordering yields higher EM than reversed. Second, and crucially, within each evidence configuration, our document reordering produces identical quality. Delta EM equals zero, Delta F1 equals zero. This is because we change only the order of passages in the prompt, not their content.</a:t>
@@ -693,7 +495,7 @@
             <a:spLocks noGrp="1"/>
           </p:cNvSpPr>
           <p:nvPr>
-            <p:ph type="sldNum" idx="5" sz="quarter"/>
+            <p:ph type="sldNum" sz="quarter" idx="5"/>
           </p:nvPr>
         </p:nvSpPr>
         <p:spPr/>
@@ -707,7 +509,7 @@
 </file>
 
 <file path=ppt/notesSlides/notesSlide12.xml><?xml version="1.0" encoding="utf-8"?>
-<p:notes xmlns:a="http://schemas.openxmlformats.org/drawingml/2006/main" xmlns:p="http://schemas.openxmlformats.org/presentationml/2006/main" xmlns:r="http://schemas.openxmlformats.org/officeDocument/2006/relationships">
+<p:notes xmlns:a="http://schemas.openxmlformats.org/drawingml/2006/main" xmlns:r="http://schemas.openxmlformats.org/officeDocument/2006/relationships" xmlns:p="http://schemas.openxmlformats.org/presentationml/2006/main">
   <p:cSld>
     <p:spTree>
       <p:nvGrpSpPr>
@@ -727,7 +529,7 @@
         <p:nvSpPr>
           <p:cNvPr id="2" name="Slide Image Placeholder 1"/>
           <p:cNvSpPr>
-            <a:spLocks noGrp="1"/>
+            <a:spLocks noGrp="1" noRot="1" noChangeAspect="1"/>
           </p:cNvSpPr>
           <p:nvPr>
             <p:ph type="sldImg" idx="2"/>
@@ -742,7 +544,7 @@
             <a:spLocks noGrp="1"/>
           </p:cNvSpPr>
           <p:nvPr>
-            <p:ph type="body" idx="3" sz="quarter"/>
+            <p:ph type="body" sz="quarter" idx="3"/>
           </p:nvPr>
         </p:nvSpPr>
         <p:spPr/>
@@ -754,25 +556,33 @@
               <a:t>Beyond synthetic benchmarks, we evaluate on four diverse workloads.</a:t>
             </a:r>
           </a:p>
-          <a:p/>
+          <a:p>
+            <a:endParaRPr/>
+          </a:p>
           <a:p>
             <a:r>
               <a:t>On a geospatial workload with natural spatial locality — Jaccard 0.17 — we see 4.5% improvement. The lower gain is expected: with low overlap, there's less room for prefix optimization.</a:t>
             </a:r>
           </a:p>
-          <a:p/>
+          <a:p>
+            <a:endParaRPr/>
+          </a:p>
           <a:p>
             <a:r>
               <a:t>On NQ-Open with very high overlap — Jaccard 0.88 — we see only 2.3%, because retrieval order already produces near-maximal prefix alignment at such high overlap.</a:t>
             </a:r>
           </a:p>
-          <a:p/>
+          <a:p>
+            <a:endParaRPr/>
+          </a:p>
           <a:p>
             <a:r>
               <a:t>On a mixed-topic workload with 30% topic switching — Jaccard 0.31 — we get 16.3% improvement. And on a real corpus of 1000 Wikipedia passages with TF-IDF retrieval and NO controlled overlap parameter, we still achieve 10.2%.</a:t>
             </a:r>
           </a:p>
-          <a:p/>
+          <a:p>
+            <a:endParaRPr/>
+          </a:p>
           <a:p>
             <a:r>
               <a:t>The pattern is clear: ordering benefits scale with the moderate-overlap regime, Jaccard around 0.3 to 0.5, which characterizes real multi-topic RAG deployments where users shift between related subjects.</a:t>
@@ -787,7 +597,7 @@
             <a:spLocks noGrp="1"/>
           </p:cNvSpPr>
           <p:nvPr>
-            <p:ph type="sldNum" idx="5" sz="quarter"/>
+            <p:ph type="sldNum" sz="quarter" idx="5"/>
           </p:nvPr>
         </p:nvSpPr>
         <p:spPr/>
@@ -801,7 +611,7 @@
 </file>
 
 <file path=ppt/notesSlides/notesSlide13.xml><?xml version="1.0" encoding="utf-8"?>
-<p:notes xmlns:a="http://schemas.openxmlformats.org/drawingml/2006/main" xmlns:p="http://schemas.openxmlformats.org/presentationml/2006/main" xmlns:r="http://schemas.openxmlformats.org/officeDocument/2006/relationships">
+<p:notes xmlns:a="http://schemas.openxmlformats.org/drawingml/2006/main" xmlns:r="http://schemas.openxmlformats.org/officeDocument/2006/relationships" xmlns:p="http://schemas.openxmlformats.org/presentationml/2006/main">
   <p:cSld>
     <p:spTree>
       <p:nvGrpSpPr>
@@ -821,7 +631,7 @@
         <p:nvSpPr>
           <p:cNvPr id="2" name="Slide Image Placeholder 1"/>
           <p:cNvSpPr>
-            <a:spLocks noGrp="1"/>
+            <a:spLocks noGrp="1" noRot="1" noChangeAspect="1"/>
           </p:cNvSpPr>
           <p:nvPr>
             <p:ph type="sldImg" idx="2"/>
@@ -836,7 +646,7 @@
             <a:spLocks noGrp="1"/>
           </p:cNvSpPr>
           <p:nvPr>
-            <p:ph type="body" idx="3" sz="quarter"/>
+            <p:ph type="body" sz="quarter" idx="3"/>
           </p:nvPr>
         </p:nvSpPr>
         <p:spPr/>
@@ -848,19 +658,25 @@
               <a:t>From a systems perspective, our overhead is minimal. The ordering step takes 22.2 microseconds, prompt construction 44.4 microseconds — together 66 microseconds or less than 0.13% of total latency. Meanwhile, inference p50 drops by 29%.</a:t>
             </a:r>
           </a:p>
-          <a:p/>
+          <a:p>
+            <a:endParaRPr/>
+          </a:p>
           <a:p>
             <a:r>
               <a:t>Throughput is completely unaffected. Both sequential and batched processing show identical throughput because ordering affects only the prefill path, not decode.</a:t>
             </a:r>
           </a:p>
-          <a:p/>
+          <a:p>
+            <a:endParaRPr/>
+          </a:p>
           <a:p>
             <a:r>
               <a:t>GPU memory is identical — vLLM pre-allocates a fixed KV cache pool. Our ordering changes which blocks within this pool are reused, not the pool size itself. The knowledge tree resides in host memory and uses less than 1 megabyte.</a:t>
             </a:r>
           </a:p>
-          <a:p/>
+          <a:p>
+            <a:endParaRPr/>
+          </a:p>
           <a:p>
             <a:r>
               <a:t>For pipelining, we overlap system prompt prefill with retrieval using a simple ThreadPoolExecutor. At a realistic 50 millisecond retrieval latency, this reduces cold-start TTFT from 106.8 to 78.8 milliseconds — a 26% reduction. No engine modifications needed.</a:t>
@@ -875,7 +691,7 @@
             <a:spLocks noGrp="1"/>
           </p:cNvSpPr>
           <p:nvPr>
-            <p:ph type="sldNum" idx="5" sz="quarter"/>
+            <p:ph type="sldNum" sz="quarter" idx="5"/>
           </p:nvPr>
         </p:nvSpPr>
         <p:spPr/>
@@ -889,7 +705,7 @@
 </file>
 
 <file path=ppt/notesSlides/notesSlide14.xml><?xml version="1.0" encoding="utf-8"?>
-<p:notes xmlns:a="http://schemas.openxmlformats.org/drawingml/2006/main" xmlns:p="http://schemas.openxmlformats.org/presentationml/2006/main" xmlns:r="http://schemas.openxmlformats.org/officeDocument/2006/relationships">
+<p:notes xmlns:a="http://schemas.openxmlformats.org/drawingml/2006/main" xmlns:r="http://schemas.openxmlformats.org/officeDocument/2006/relationships" xmlns:p="http://schemas.openxmlformats.org/presentationml/2006/main">
   <p:cSld>
     <p:spTree>
       <p:nvGrpSpPr>
@@ -909,7 +725,7 @@
         <p:nvSpPr>
           <p:cNvPr id="2" name="Slide Image Placeholder 1"/>
           <p:cNvSpPr>
-            <a:spLocks noGrp="1"/>
+            <a:spLocks noGrp="1" noRot="1" noChangeAspect="1"/>
           </p:cNvSpPr>
           <p:nvPr>
             <p:ph type="sldImg" idx="2"/>
@@ -924,7 +740,7 @@
             <a:spLocks noGrp="1"/>
           </p:cNvSpPr>
           <p:nvPr>
-            <p:ph type="body" idx="3" sz="quarter"/>
+            <p:ph type="body" sz="quarter" idx="3"/>
           </p:nvPr>
         </p:nvSpPr>
         <p:spPr/>
@@ -945,7 +761,7 @@
             <a:spLocks noGrp="1"/>
           </p:cNvSpPr>
           <p:nvPr>
-            <p:ph type="sldNum" idx="5" sz="quarter"/>
+            <p:ph type="sldNum" sz="quarter" idx="5"/>
           </p:nvPr>
         </p:nvSpPr>
         <p:spPr/>
@@ -959,7 +775,7 @@
 </file>
 
 <file path=ppt/notesSlides/notesSlide15.xml><?xml version="1.0" encoding="utf-8"?>
-<p:notes xmlns:a="http://schemas.openxmlformats.org/drawingml/2006/main" xmlns:p="http://schemas.openxmlformats.org/presentationml/2006/main" xmlns:r="http://schemas.openxmlformats.org/officeDocument/2006/relationships">
+<p:notes xmlns:a="http://schemas.openxmlformats.org/drawingml/2006/main" xmlns:r="http://schemas.openxmlformats.org/officeDocument/2006/relationships" xmlns:p="http://schemas.openxmlformats.org/presentationml/2006/main">
   <p:cSld>
     <p:spTree>
       <p:nvGrpSpPr>
@@ -979,7 +795,7 @@
         <p:nvSpPr>
           <p:cNvPr id="2" name="Slide Image Placeholder 1"/>
           <p:cNvSpPr>
-            <a:spLocks noGrp="1"/>
+            <a:spLocks noGrp="1" noRot="1" noChangeAspect="1"/>
           </p:cNvSpPr>
           <p:nvPr>
             <p:ph type="sldImg" idx="2"/>
@@ -994,7 +810,7 @@
             <a:spLocks noGrp="1"/>
           </p:cNvSpPr>
           <p:nvPr>
-            <p:ph type="body" idx="3" sz="quarter"/>
+            <p:ph type="body" sz="quarter" idx="3"/>
           </p:nvPr>
         </p:nvSpPr>
         <p:spPr/>
@@ -1006,19 +822,25 @@
               <a:t>In conclusion, RAGCache++ demonstrates that a thin prompt-layer scheduling policy can recover substantial cache locality in RAG serving.</a:t>
             </a:r>
           </a:p>
-          <a:p/>
+          <a:p>
+            <a:endParaRPr/>
+          </a:p>
           <a:p>
             <a:r>
               <a:t>Our headline results: 20 to 33% TTFT reduction with less than 0.13% overhead. 66% of prefill computation saved at the median. 97.5% of oracle performance with an O(k) greedy algorithm. All with about 150 lines of Python and zero engine modifications.</a:t>
             </a:r>
           </a:p>
-          <a:p/>
+          <a:p>
+            <a:endParaRPr/>
+          </a:p>
           <a:p>
             <a:r>
               <a:t>The closed-loop feedback mechanism achieves 99.5% prediction accuracy, keeping the trie synchronized with vLLM's actual cache state. And the approach generalizes across 4 model sizes, 2 architectures, and 5 diverse workloads.</a:t>
             </a:r>
           </a:p>
-          <a:p/>
+          <a:p>
+            <a:endParaRPr/>
+          </a:p>
           <a:p>
             <a:r>
               <a:t>Our key systems insight is that prefix depth — not hit count — is the relevant metric for latency reduction in prefix-caching systems. Thank you.</a:t>
@@ -1033,7 +855,7 @@
             <a:spLocks noGrp="1"/>
           </p:cNvSpPr>
           <p:nvPr>
-            <p:ph type="sldNum" idx="5" sz="quarter"/>
+            <p:ph type="sldNum" sz="quarter" idx="5"/>
           </p:nvPr>
         </p:nvSpPr>
         <p:spPr/>
@@ -1047,7 +869,7 @@
 </file>
 
 <file path=ppt/notesSlides/notesSlide16.xml><?xml version="1.0" encoding="utf-8"?>
-<p:notes xmlns:a="http://schemas.openxmlformats.org/drawingml/2006/main" xmlns:p="http://schemas.openxmlformats.org/presentationml/2006/main" xmlns:r="http://schemas.openxmlformats.org/officeDocument/2006/relationships">
+<p:notes xmlns:a="http://schemas.openxmlformats.org/drawingml/2006/main" xmlns:r="http://schemas.openxmlformats.org/officeDocument/2006/relationships" xmlns:p="http://schemas.openxmlformats.org/presentationml/2006/main">
   <p:cSld>
     <p:spTree>
       <p:nvGrpSpPr>
@@ -1067,7 +889,7 @@
         <p:nvSpPr>
           <p:cNvPr id="2" name="Slide Image Placeholder 1"/>
           <p:cNvSpPr>
-            <a:spLocks noGrp="1"/>
+            <a:spLocks noGrp="1" noRot="1" noChangeAspect="1"/>
           </p:cNvSpPr>
           <p:nvPr>
             <p:ph type="sldImg" idx="2"/>
@@ -1082,7 +904,7 @@
             <a:spLocks noGrp="1"/>
           </p:cNvSpPr>
           <p:nvPr>
-            <p:ph type="body" idx="3" sz="quarter"/>
+            <p:ph type="body" sz="quarter" idx="3"/>
           </p:nvPr>
         </p:nvSpPr>
         <p:spPr/>
@@ -1094,7 +916,9 @@
               <a:t>Thank you for your attention. We're happy to take any questions about RAGCache++, our experimental methodology, or the systems insights we've discussed.</a:t>
             </a:r>
           </a:p>
-          <a:p/>
+          <a:p>
+            <a:endParaRPr/>
+          </a:p>
           <a:p>
             <a:r>
               <a:t>The code is available at github.com/tantansir/RAGCachePlusPlus.</a:t>
@@ -1109,7 +933,7 @@
             <a:spLocks noGrp="1"/>
           </p:cNvSpPr>
           <p:nvPr>
-            <p:ph type="sldNum" idx="5" sz="quarter"/>
+            <p:ph type="sldNum" sz="quarter" idx="5"/>
           </p:nvPr>
         </p:nvSpPr>
         <p:spPr/>
@@ -1123,7 +947,7 @@
 </file>
 
 <file path=ppt/notesSlides/notesSlide2.xml><?xml version="1.0" encoding="utf-8"?>
-<p:notes xmlns:a="http://schemas.openxmlformats.org/drawingml/2006/main" xmlns:p="http://schemas.openxmlformats.org/presentationml/2006/main" xmlns:r="http://schemas.openxmlformats.org/officeDocument/2006/relationships">
+<p:notes xmlns:a="http://schemas.openxmlformats.org/drawingml/2006/main" xmlns:r="http://schemas.openxmlformats.org/officeDocument/2006/relationships" xmlns:p="http://schemas.openxmlformats.org/presentationml/2006/main">
   <p:cSld>
     <p:spTree>
       <p:nvGrpSpPr>
@@ -1143,7 +967,7 @@
         <p:nvSpPr>
           <p:cNvPr id="2" name="Slide Image Placeholder 1"/>
           <p:cNvSpPr>
-            <a:spLocks noGrp="1"/>
+            <a:spLocks noGrp="1" noRot="1" noChangeAspect="1"/>
           </p:cNvSpPr>
           <p:nvPr>
             <p:ph type="sldImg" idx="2"/>
@@ -1158,7 +982,7 @@
             <a:spLocks noGrp="1"/>
           </p:cNvSpPr>
           <p:nvPr>
-            <p:ph type="body" idx="3" sz="quarter"/>
+            <p:ph type="body" sz="quarter" idx="3"/>
           </p:nvPr>
         </p:nvSpPr>
         <p:spPr/>
@@ -1170,7 +994,9 @@
               <a:t>RAG improves LLM accuracy by injecting retrieved passages into the prompt, but this comes at a significant cost. Prompts become 2 to 10 times longer, and since prefill computation scales linearly with input length, this directly inflates Time-To-First-Token — the metric users feel most.</a:t>
             </a:r>
           </a:p>
-          <a:p/>
+          <a:p>
+            <a:endParaRPr/>
+          </a:p>
           <a:p>
             <a:r>
               <a:t>In a typical RAG pipeline, query embedding and vector retrieval take about 10 to 50 milliseconds. But the LLM prefill — step 4 — can take 50 to 200 or more milliseconds, dominating total latency. Our goal is to reduce this prefill cost without modifying the serving engine itself.</a:t>
@@ -1185,7 +1011,7 @@
             <a:spLocks noGrp="1"/>
           </p:cNvSpPr>
           <p:nvPr>
-            <p:ph type="sldNum" idx="5" sz="quarter"/>
+            <p:ph type="sldNum" sz="quarter" idx="5"/>
           </p:nvPr>
         </p:nvSpPr>
         <p:spPr/>
@@ -1199,7 +1025,7 @@
 </file>
 
 <file path=ppt/notesSlides/notesSlide3.xml><?xml version="1.0" encoding="utf-8"?>
-<p:notes xmlns:a="http://schemas.openxmlformats.org/drawingml/2006/main" xmlns:p="http://schemas.openxmlformats.org/presentationml/2006/main" xmlns:r="http://schemas.openxmlformats.org/officeDocument/2006/relationships">
+<p:notes xmlns:a="http://schemas.openxmlformats.org/drawingml/2006/main" xmlns:r="http://schemas.openxmlformats.org/officeDocument/2006/relationships" xmlns:p="http://schemas.openxmlformats.org/presentationml/2006/main">
   <p:cSld>
     <p:spTree>
       <p:nvGrpSpPr>
@@ -1219,7 +1045,7 @@
         <p:nvSpPr>
           <p:cNvPr id="2" name="Slide Image Placeholder 1"/>
           <p:cNvSpPr>
-            <a:spLocks noGrp="1"/>
+            <a:spLocks noGrp="1" noRot="1" noChangeAspect="1"/>
           </p:cNvSpPr>
           <p:nvPr>
             <p:ph type="sldImg" idx="2"/>
@@ -1234,7 +1060,7 @@
             <a:spLocks noGrp="1"/>
           </p:cNvSpPr>
           <p:nvPr>
-            <p:ph type="body" idx="3" sz="quarter"/>
+            <p:ph type="body" sz="quarter" idx="3"/>
           </p:nvPr>
         </p:nvSpPr>
         <p:spPr/>
@@ -1255,7 +1081,7 @@
             <a:spLocks noGrp="1"/>
           </p:cNvSpPr>
           <p:nvPr>
-            <p:ph type="sldNum" idx="5" sz="quarter"/>
+            <p:ph type="sldNum" sz="quarter" idx="5"/>
           </p:nvPr>
         </p:nvSpPr>
         <p:spPr/>
@@ -1269,7 +1095,7 @@
 </file>
 
 <file path=ppt/notesSlides/notesSlide4.xml><?xml version="1.0" encoding="utf-8"?>
-<p:notes xmlns:a="http://schemas.openxmlformats.org/drawingml/2006/main" xmlns:p="http://schemas.openxmlformats.org/presentationml/2006/main" xmlns:r="http://schemas.openxmlformats.org/officeDocument/2006/relationships">
+<p:notes xmlns:a="http://schemas.openxmlformats.org/drawingml/2006/main" xmlns:r="http://schemas.openxmlformats.org/officeDocument/2006/relationships" xmlns:p="http://schemas.openxmlformats.org/presentationml/2006/main">
   <p:cSld>
     <p:spTree>
       <p:nvGrpSpPr>
@@ -1289,7 +1115,7 @@
         <p:nvSpPr>
           <p:cNvPr id="2" name="Slide Image Placeholder 1"/>
           <p:cNvSpPr>
-            <a:spLocks noGrp="1"/>
+            <a:spLocks noGrp="1" noRot="1" noChangeAspect="1"/>
           </p:cNvSpPr>
           <p:nvPr>
             <p:ph type="sldImg" idx="2"/>
@@ -1304,7 +1130,7 @@
             <a:spLocks noGrp="1"/>
           </p:cNvSpPr>
           <p:nvPr>
-            <p:ph type="body" idx="3" sz="quarter"/>
+            <p:ph type="body" sz="quarter" idx="3"/>
           </p:nvPr>
         </p:nvSpPr>
         <p:spPr/>
@@ -1316,13 +1142,17 @@
               <a:t>Our approach is straightforward. Since APC requires exact token-level prefix matches, we can maximize cache reuse simply by reordering documents to align with cached prefixes.</a:t>
             </a:r>
           </a:p>
-          <a:p/>
+          <a:p>
+            <a:endParaRPr/>
+          </a:p>
           <a:p>
             <a:r>
               <a:t>RAGCache++ has three core components. First, a knowledge tree — a trie indexed by document-ID sequences — that tracks which orderings are currently in the KV cache. Second, a greedy O(k) algorithm that walks the trie to find the longest cached prefix for each new request. Third, the entire system requires zero modifications to vLLM — it's about 150 lines of Python operating purely at the prompt-construction layer.</a:t>
             </a:r>
           </a:p>
-          <a:p/>
+          <a:p>
+            <a:endParaRPr/>
+          </a:p>
           <a:p>
             <a:r>
               <a:t>The analogy is a disk I/O scheduler: it reorders requests to exploit spatial locality without modifying the disk firmware. We do the same for KV cache locality.</a:t>
@@ -1337,7 +1167,7 @@
             <a:spLocks noGrp="1"/>
           </p:cNvSpPr>
           <p:nvPr>
-            <p:ph type="sldNum" idx="5" sz="quarter"/>
+            <p:ph type="sldNum" sz="quarter" idx="5"/>
           </p:nvPr>
         </p:nvSpPr>
         <p:spPr/>
@@ -1351,7 +1181,7 @@
 </file>
 
 <file path=ppt/notesSlides/notesSlide5.xml><?xml version="1.0" encoding="utf-8"?>
-<p:notes xmlns:a="http://schemas.openxmlformats.org/drawingml/2006/main" xmlns:p="http://schemas.openxmlformats.org/presentationml/2006/main" xmlns:r="http://schemas.openxmlformats.org/officeDocument/2006/relationships">
+<p:notes xmlns:a="http://schemas.openxmlformats.org/drawingml/2006/main" xmlns:r="http://schemas.openxmlformats.org/officeDocument/2006/relationships" xmlns:p="http://schemas.openxmlformats.org/presentationml/2006/main">
   <p:cSld>
     <p:spTree>
       <p:nvGrpSpPr>
@@ -1371,7 +1201,7 @@
         <p:nvSpPr>
           <p:cNvPr id="2" name="Slide Image Placeholder 1"/>
           <p:cNvSpPr>
-            <a:spLocks noGrp="1"/>
+            <a:spLocks noGrp="1" noRot="1" noChangeAspect="1"/>
           </p:cNvSpPr>
           <p:nvPr>
             <p:ph type="sldImg" idx="2"/>
@@ -1386,7 +1216,7 @@
             <a:spLocks noGrp="1"/>
           </p:cNvSpPr>
           <p:nvPr>
-            <p:ph type="body" idx="3" sz="quarter"/>
+            <p:ph type="body" sz="quarter" idx="3"/>
           </p:nvPr>
         </p:nvSpPr>
         <p:spPr/>
@@ -1407,7 +1237,7 @@
             <a:spLocks noGrp="1"/>
           </p:cNvSpPr>
           <p:nvPr>
-            <p:ph type="sldNum" idx="5" sz="quarter"/>
+            <p:ph type="sldNum" sz="quarter" idx="5"/>
           </p:nvPr>
         </p:nvSpPr>
         <p:spPr/>
@@ -1421,7 +1251,7 @@
 </file>
 
 <file path=ppt/notesSlides/notesSlide6.xml><?xml version="1.0" encoding="utf-8"?>
-<p:notes xmlns:a="http://schemas.openxmlformats.org/drawingml/2006/main" xmlns:p="http://schemas.openxmlformats.org/presentationml/2006/main" xmlns:r="http://schemas.openxmlformats.org/officeDocument/2006/relationships">
+<p:notes xmlns:a="http://schemas.openxmlformats.org/drawingml/2006/main" xmlns:r="http://schemas.openxmlformats.org/officeDocument/2006/relationships" xmlns:p="http://schemas.openxmlformats.org/presentationml/2006/main">
   <p:cSld>
     <p:spTree>
       <p:nvGrpSpPr>
@@ -1441,7 +1271,7 @@
         <p:nvSpPr>
           <p:cNvPr id="2" name="Slide Image Placeholder 1"/>
           <p:cNvSpPr>
-            <a:spLocks noGrp="1"/>
+            <a:spLocks noGrp="1" noRot="1" noChangeAspect="1"/>
           </p:cNvSpPr>
           <p:nvPr>
             <p:ph type="sldImg" idx="2"/>
@@ -1456,7 +1286,7 @@
             <a:spLocks noGrp="1"/>
           </p:cNvSpPr>
           <p:nvPr>
-            <p:ph type="body" idx="3" sz="quarter"/>
+            <p:ph type="body" sz="quarter" idx="3"/>
           </p:nvPr>
         </p:nvSpPr>
         <p:spPr/>
@@ -1468,13 +1298,17 @@
               <a:t>A key challenge is that the trie tracks what we've served, not what's actually resident in vLLM's cache. Under memory pressure, vLLM may evict blocks that the trie thinks are cached, leading to stale predictions.</a:t>
             </a:r>
           </a:p>
-          <a:p/>
+          <a:p>
+            <a:endParaRPr/>
+          </a:p>
           <a:p>
             <a:r>
               <a:t>We close this gap with a TTFT-based feedback loop. The system maintains a running estimate of cold-start TTFT using an exponential moving average. After each request, it compares the trie's predicted reuse fraction with the TTFT-inferred actual reuse. When the trie predicts a significant cache hit but the observed TTFT is near-cold, we detect a mismatch and prune the stale path.</a:t>
             </a:r>
           </a:p>
-          <a:p/>
+          <a:p>
+            <a:endParaRPr/>
+          </a:p>
           <a:p>
             <a:r>
               <a:t>This achieves 99.5% prediction accuracy with only 0.049 milliseconds of overhead — less than 0.1% of TTFT. The trie-reality correlation is 0.972, and it remains stable even under memory pressure at 0.965.</a:t>
@@ -1489,7 +1323,7 @@
             <a:spLocks noGrp="1"/>
           </p:cNvSpPr>
           <p:nvPr>
-            <p:ph type="sldNum" idx="5" sz="quarter"/>
+            <p:ph type="sldNum" sz="quarter" idx="5"/>
           </p:nvPr>
         </p:nvSpPr>
         <p:spPr/>
@@ -1503,7 +1337,7 @@
 </file>
 
 <file path=ppt/notesSlides/notesSlide7.xml><?xml version="1.0" encoding="utf-8"?>
-<p:notes xmlns:a="http://schemas.openxmlformats.org/drawingml/2006/main" xmlns:p="http://schemas.openxmlformats.org/presentationml/2006/main" xmlns:r="http://schemas.openxmlformats.org/officeDocument/2006/relationships">
+<p:notes xmlns:a="http://schemas.openxmlformats.org/drawingml/2006/main" xmlns:r="http://schemas.openxmlformats.org/officeDocument/2006/relationships" xmlns:p="http://schemas.openxmlformats.org/presentationml/2006/main">
   <p:cSld>
     <p:spTree>
       <p:nvGrpSpPr>
@@ -1523,7 +1357,7 @@
         <p:nvSpPr>
           <p:cNvPr id="2" name="Slide Image Placeholder 1"/>
           <p:cNvSpPr>
-            <a:spLocks noGrp="1"/>
+            <a:spLocks noGrp="1" noRot="1" noChangeAspect="1"/>
           </p:cNvSpPr>
           <p:nvPr>
             <p:ph type="sldImg" idx="2"/>
@@ -1538,7 +1372,7 @@
             <a:spLocks noGrp="1"/>
           </p:cNvSpPr>
           <p:nvPr>
-            <p:ph type="body" idx="3" sz="quarter"/>
+            <p:ph type="body" sz="quarter" idx="3"/>
           </p:nvPr>
         </p:nvSpPr>
         <p:spPr/>
@@ -1559,7 +1393,7 @@
             <a:spLocks noGrp="1"/>
           </p:cNvSpPr>
           <p:nvPr>
-            <p:ph type="sldNum" idx="5" sz="quarter"/>
+            <p:ph type="sldNum" sz="quarter" idx="5"/>
           </p:nvPr>
         </p:nvSpPr>
         <p:spPr/>
@@ -1573,7 +1407,7 @@
 </file>
 
 <file path=ppt/notesSlides/notesSlide8.xml><?xml version="1.0" encoding="utf-8"?>
-<p:notes xmlns:a="http://schemas.openxmlformats.org/drawingml/2006/main" xmlns:p="http://schemas.openxmlformats.org/presentationml/2006/main" xmlns:r="http://schemas.openxmlformats.org/officeDocument/2006/relationships">
+<p:notes xmlns:a="http://schemas.openxmlformats.org/drawingml/2006/main" xmlns:r="http://schemas.openxmlformats.org/officeDocument/2006/relationships" xmlns:p="http://schemas.openxmlformats.org/presentationml/2006/main">
   <p:cSld>
     <p:spTree>
       <p:nvGrpSpPr>
@@ -1593,7 +1427,7 @@
         <p:nvSpPr>
           <p:cNvPr id="2" name="Slide Image Placeholder 1"/>
           <p:cNvSpPr>
-            <a:spLocks noGrp="1"/>
+            <a:spLocks noGrp="1" noRot="1" noChangeAspect="1"/>
           </p:cNvSpPr>
           <p:nvPr>
             <p:ph type="sldImg" idx="2"/>
@@ -1608,7 +1442,7 @@
             <a:spLocks noGrp="1"/>
           </p:cNvSpPr>
           <p:nvPr>
-            <p:ph type="body" idx="3" sz="quarter"/>
+            <p:ph type="body" sz="quarter" idx="3"/>
           </p:nvPr>
         </p:nvSpPr>
         <p:spPr/>
@@ -1629,7 +1463,7 @@
             <a:spLocks noGrp="1"/>
           </p:cNvSpPr>
           <p:nvPr>
-            <p:ph type="sldNum" idx="5" sz="quarter"/>
+            <p:ph type="sldNum" sz="quarter" idx="5"/>
           </p:nvPr>
         </p:nvSpPr>
         <p:spPr/>
@@ -1643,7 +1477,7 @@
 </file>
 
 <file path=ppt/notesSlides/notesSlide9.xml><?xml version="1.0" encoding="utf-8"?>
-<p:notes xmlns:a="http://schemas.openxmlformats.org/drawingml/2006/main" xmlns:p="http://schemas.openxmlformats.org/presentationml/2006/main" xmlns:r="http://schemas.openxmlformats.org/officeDocument/2006/relationships">
+<p:notes xmlns:a="http://schemas.openxmlformats.org/drawingml/2006/main" xmlns:r="http://schemas.openxmlformats.org/officeDocument/2006/relationships" xmlns:p="http://schemas.openxmlformats.org/presentationml/2006/main">
   <p:cSld>
     <p:spTree>
       <p:nvGrpSpPr>
@@ -1663,7 +1497,7 @@
         <p:nvSpPr>
           <p:cNvPr id="2" name="Slide Image Placeholder 1"/>
           <p:cNvSpPr>
-            <a:spLocks noGrp="1"/>
+            <a:spLocks noGrp="1" noRot="1" noChangeAspect="1"/>
           </p:cNvSpPr>
           <p:nvPr>
             <p:ph type="sldImg" idx="2"/>
@@ -1678,7 +1512,7 @@
             <a:spLocks noGrp="1"/>
           </p:cNvSpPr>
           <p:nvPr>
-            <p:ph type="body" idx="3" sz="quarter"/>
+            <p:ph type="body" sz="quarter" idx="3"/>
           </p:nvPr>
         </p:nvSpPr>
         <p:spPr/>
@@ -1699,7 +1533,7 @@
             <a:spLocks noGrp="1"/>
           </p:cNvSpPr>
           <p:nvPr>
-            <p:ph type="sldNum" idx="5" sz="quarter"/>
+            <p:ph type="sldNum" sz="quarter" idx="5"/>
           </p:nvPr>
         </p:nvSpPr>
         <p:spPr/>
@@ -1750,10 +1584,9 @@
           <a:lstStyle/>
           <a:p>
             <a:r>
-              <a:rPr lang="en-US" smtClean="0"/>
+              <a:rPr lang="en-US"/>
               <a:t>Click to edit Master title style</a:t>
             </a:r>
-            <a:endParaRPr lang="en-US"/>
           </a:p>
         </p:txBody>
       </p:sp>
@@ -1869,10 +1702,9 @@
           </a:lstStyle>
           <a:p>
             <a:r>
-              <a:rPr lang="en-US" smtClean="0"/>
+              <a:rPr lang="en-US"/>
               <a:t>Click to edit Master subtitle style</a:t>
             </a:r>
-            <a:endParaRPr lang="en-US"/>
           </a:p>
         </p:txBody>
       </p:sp>
@@ -1893,7 +1725,7 @@
           <a:p>
             <a:fld id="{5BCAD085-E8A6-8845-BD4E-CB4CCA059FC4}" type="datetimeFigureOut">
               <a:rPr lang="en-US" smtClean="0"/>
-              <a:t>1/27/13</a:t>
+              <a:t>4/15/2026</a:t>
             </a:fld>
             <a:endParaRPr lang="en-US"/>
           </a:p>
@@ -1987,10 +1819,9 @@
           <a:lstStyle/>
           <a:p>
             <a:r>
-              <a:rPr lang="en-US" smtClean="0"/>
+              <a:rPr lang="en-US"/>
               <a:t>Click to edit Master title style</a:t>
             </a:r>
-            <a:endParaRPr lang="en-US"/>
           </a:p>
         </p:txBody>
       </p:sp>
@@ -2011,38 +1842,37 @@
           <a:p>
             <a:pPr lvl="0"/>
             <a:r>
-              <a:rPr lang="en-US" smtClean="0"/>
+              <a:rPr lang="en-US"/>
               <a:t>Click to edit Master text styles</a:t>
             </a:r>
           </a:p>
           <a:p>
             <a:pPr lvl="1"/>
             <a:r>
-              <a:rPr lang="en-US" smtClean="0"/>
+              <a:rPr lang="en-US"/>
               <a:t>Second level</a:t>
             </a:r>
           </a:p>
           <a:p>
             <a:pPr lvl="2"/>
             <a:r>
-              <a:rPr lang="en-US" smtClean="0"/>
+              <a:rPr lang="en-US"/>
               <a:t>Third level</a:t>
             </a:r>
           </a:p>
           <a:p>
             <a:pPr lvl="3"/>
             <a:r>
-              <a:rPr lang="en-US" smtClean="0"/>
+              <a:rPr lang="en-US"/>
               <a:t>Fourth level</a:t>
             </a:r>
           </a:p>
           <a:p>
             <a:pPr lvl="4"/>
             <a:r>
-              <a:rPr lang="en-US" smtClean="0"/>
+              <a:rPr lang="en-US"/>
               <a:t>Fifth level</a:t>
             </a:r>
-            <a:endParaRPr lang="en-US"/>
           </a:p>
         </p:txBody>
       </p:sp>
@@ -2063,7 +1893,7 @@
           <a:p>
             <a:fld id="{5BCAD085-E8A6-8845-BD4E-CB4CCA059FC4}" type="datetimeFigureOut">
               <a:rPr lang="en-US" smtClean="0"/>
-              <a:t>1/27/13</a:t>
+              <a:t>4/15/2026</a:t>
             </a:fld>
             <a:endParaRPr lang="en-US"/>
           </a:p>
@@ -2162,10 +1992,9 @@
           <a:lstStyle/>
           <a:p>
             <a:r>
-              <a:rPr lang="en-US" smtClean="0"/>
+              <a:rPr lang="en-US"/>
               <a:t>Click to edit Master title style</a:t>
             </a:r>
-            <a:endParaRPr lang="en-US"/>
           </a:p>
         </p:txBody>
       </p:sp>
@@ -2191,38 +2020,37 @@
           <a:p>
             <a:pPr lvl="0"/>
             <a:r>
-              <a:rPr lang="en-US" smtClean="0"/>
+              <a:rPr lang="en-US"/>
               <a:t>Click to edit Master text styles</a:t>
             </a:r>
           </a:p>
           <a:p>
             <a:pPr lvl="1"/>
             <a:r>
-              <a:rPr lang="en-US" smtClean="0"/>
+              <a:rPr lang="en-US"/>
               <a:t>Second level</a:t>
             </a:r>
           </a:p>
           <a:p>
             <a:pPr lvl="2"/>
             <a:r>
-              <a:rPr lang="en-US" smtClean="0"/>
+              <a:rPr lang="en-US"/>
               <a:t>Third level</a:t>
             </a:r>
           </a:p>
           <a:p>
             <a:pPr lvl="3"/>
             <a:r>
-              <a:rPr lang="en-US" smtClean="0"/>
+              <a:rPr lang="en-US"/>
               <a:t>Fourth level</a:t>
             </a:r>
           </a:p>
           <a:p>
             <a:pPr lvl="4"/>
             <a:r>
-              <a:rPr lang="en-US" smtClean="0"/>
+              <a:rPr lang="en-US"/>
               <a:t>Fifth level</a:t>
             </a:r>
-            <a:endParaRPr lang="en-US"/>
           </a:p>
         </p:txBody>
       </p:sp>
@@ -2243,7 +2071,7 @@
           <a:p>
             <a:fld id="{5BCAD085-E8A6-8845-BD4E-CB4CCA059FC4}" type="datetimeFigureOut">
               <a:rPr lang="en-US" smtClean="0"/>
-              <a:t>1/27/13</a:t>
+              <a:t>4/15/2026</a:t>
             </a:fld>
             <a:endParaRPr lang="en-US"/>
           </a:p>
@@ -2337,10 +2165,9 @@
           <a:lstStyle/>
           <a:p>
             <a:r>
-              <a:rPr lang="en-US" smtClean="0"/>
+              <a:rPr lang="en-US"/>
               <a:t>Click to edit Master title style</a:t>
             </a:r>
-            <a:endParaRPr lang="en-US"/>
           </a:p>
         </p:txBody>
       </p:sp>
@@ -2361,38 +2188,37 @@
           <a:p>
             <a:pPr lvl="0"/>
             <a:r>
-              <a:rPr lang="en-US" smtClean="0"/>
+              <a:rPr lang="en-US"/>
               <a:t>Click to edit Master text styles</a:t>
             </a:r>
           </a:p>
           <a:p>
             <a:pPr lvl="1"/>
             <a:r>
-              <a:rPr lang="en-US" smtClean="0"/>
+              <a:rPr lang="en-US"/>
               <a:t>Second level</a:t>
             </a:r>
           </a:p>
           <a:p>
             <a:pPr lvl="2"/>
             <a:r>
-              <a:rPr lang="en-US" smtClean="0"/>
+              <a:rPr lang="en-US"/>
               <a:t>Third level</a:t>
             </a:r>
           </a:p>
           <a:p>
             <a:pPr lvl="3"/>
             <a:r>
-              <a:rPr lang="en-US" smtClean="0"/>
+              <a:rPr lang="en-US"/>
               <a:t>Fourth level</a:t>
             </a:r>
           </a:p>
           <a:p>
             <a:pPr lvl="4"/>
             <a:r>
-              <a:rPr lang="en-US" smtClean="0"/>
+              <a:rPr lang="en-US"/>
               <a:t>Fifth level</a:t>
             </a:r>
-            <a:endParaRPr lang="en-US"/>
           </a:p>
         </p:txBody>
       </p:sp>
@@ -2413,7 +2239,7 @@
           <a:p>
             <a:fld id="{5BCAD085-E8A6-8845-BD4E-CB4CCA059FC4}" type="datetimeFigureOut">
               <a:rPr lang="en-US" smtClean="0"/>
-              <a:t>1/27/13</a:t>
+              <a:t>4/15/2026</a:t>
             </a:fld>
             <a:endParaRPr lang="en-US"/>
           </a:p>
@@ -2516,10 +2342,9 @@
           </a:lstStyle>
           <a:p>
             <a:r>
-              <a:rPr lang="en-US" smtClean="0"/>
+              <a:rPr lang="en-US"/>
               <a:t>Click to edit Master title style</a:t>
             </a:r>
-            <a:endParaRPr lang="en-US"/>
           </a:p>
         </p:txBody>
       </p:sp>
@@ -2636,7 +2461,7 @@
           <a:p>
             <a:pPr lvl="0"/>
             <a:r>
-              <a:rPr lang="en-US" smtClean="0"/>
+              <a:rPr lang="en-US"/>
               <a:t>Click to edit Master text styles</a:t>
             </a:r>
           </a:p>
@@ -2659,7 +2484,7 @@
           <a:p>
             <a:fld id="{5BCAD085-E8A6-8845-BD4E-CB4CCA059FC4}" type="datetimeFigureOut">
               <a:rPr lang="en-US" smtClean="0"/>
-              <a:t>1/27/13</a:t>
+              <a:t>4/15/2026</a:t>
             </a:fld>
             <a:endParaRPr lang="en-US"/>
           </a:p>
@@ -2753,10 +2578,9 @@
           <a:lstStyle/>
           <a:p>
             <a:r>
-              <a:rPr lang="en-US" smtClean="0"/>
+              <a:rPr lang="en-US"/>
               <a:t>Click to edit Master title style</a:t>
             </a:r>
-            <a:endParaRPr lang="en-US"/>
           </a:p>
         </p:txBody>
       </p:sp>
@@ -2810,38 +2634,37 @@
           <a:p>
             <a:pPr lvl="0"/>
             <a:r>
-              <a:rPr lang="en-US" smtClean="0"/>
+              <a:rPr lang="en-US"/>
               <a:t>Click to edit Master text styles</a:t>
             </a:r>
           </a:p>
           <a:p>
             <a:pPr lvl="1"/>
             <a:r>
-              <a:rPr lang="en-US" smtClean="0"/>
+              <a:rPr lang="en-US"/>
               <a:t>Second level</a:t>
             </a:r>
           </a:p>
           <a:p>
             <a:pPr lvl="2"/>
             <a:r>
-              <a:rPr lang="en-US" smtClean="0"/>
+              <a:rPr lang="en-US"/>
               <a:t>Third level</a:t>
             </a:r>
           </a:p>
           <a:p>
             <a:pPr lvl="3"/>
             <a:r>
-              <a:rPr lang="en-US" smtClean="0"/>
+              <a:rPr lang="en-US"/>
               <a:t>Fourth level</a:t>
             </a:r>
           </a:p>
           <a:p>
             <a:pPr lvl="4"/>
             <a:r>
-              <a:rPr lang="en-US" smtClean="0"/>
+              <a:rPr lang="en-US"/>
               <a:t>Fifth level</a:t>
             </a:r>
-            <a:endParaRPr lang="en-US"/>
           </a:p>
         </p:txBody>
       </p:sp>
@@ -2895,38 +2718,37 @@
           <a:p>
             <a:pPr lvl="0"/>
             <a:r>
-              <a:rPr lang="en-US" smtClean="0"/>
+              <a:rPr lang="en-US"/>
               <a:t>Click to edit Master text styles</a:t>
             </a:r>
           </a:p>
           <a:p>
             <a:pPr lvl="1"/>
             <a:r>
-              <a:rPr lang="en-US" smtClean="0"/>
+              <a:rPr lang="en-US"/>
               <a:t>Second level</a:t>
             </a:r>
           </a:p>
           <a:p>
             <a:pPr lvl="2"/>
             <a:r>
-              <a:rPr lang="en-US" smtClean="0"/>
+              <a:rPr lang="en-US"/>
               <a:t>Third level</a:t>
             </a:r>
           </a:p>
           <a:p>
             <a:pPr lvl="3"/>
             <a:r>
-              <a:rPr lang="en-US" smtClean="0"/>
+              <a:rPr lang="en-US"/>
               <a:t>Fourth level</a:t>
             </a:r>
           </a:p>
           <a:p>
             <a:pPr lvl="4"/>
             <a:r>
-              <a:rPr lang="en-US" smtClean="0"/>
+              <a:rPr lang="en-US"/>
               <a:t>Fifth level</a:t>
             </a:r>
-            <a:endParaRPr lang="en-US"/>
           </a:p>
         </p:txBody>
       </p:sp>
@@ -2947,7 +2769,7 @@
           <a:p>
             <a:fld id="{5BCAD085-E8A6-8845-BD4E-CB4CCA059FC4}" type="datetimeFigureOut">
               <a:rPr lang="en-US" smtClean="0"/>
-              <a:t>1/27/13</a:t>
+              <a:t>4/15/2026</a:t>
             </a:fld>
             <a:endParaRPr lang="en-US"/>
           </a:p>
@@ -3045,10 +2867,9 @@
           </a:lstStyle>
           <a:p>
             <a:r>
-              <a:rPr lang="en-US" smtClean="0"/>
+              <a:rPr lang="en-US"/>
               <a:t>Click to edit Master title style</a:t>
             </a:r>
-            <a:endParaRPr lang="en-US"/>
           </a:p>
         </p:txBody>
       </p:sp>
@@ -3111,7 +2932,7 @@
           <a:p>
             <a:pPr lvl="0"/>
             <a:r>
-              <a:rPr lang="en-US" smtClean="0"/>
+              <a:rPr lang="en-US"/>
               <a:t>Click to edit Master text styles</a:t>
             </a:r>
           </a:p>
@@ -3167,38 +2988,37 @@
           <a:p>
             <a:pPr lvl="0"/>
             <a:r>
-              <a:rPr lang="en-US" smtClean="0"/>
+              <a:rPr lang="en-US"/>
               <a:t>Click to edit Master text styles</a:t>
             </a:r>
           </a:p>
           <a:p>
             <a:pPr lvl="1"/>
             <a:r>
-              <a:rPr lang="en-US" smtClean="0"/>
+              <a:rPr lang="en-US"/>
               <a:t>Second level</a:t>
             </a:r>
           </a:p>
           <a:p>
             <a:pPr lvl="2"/>
             <a:r>
-              <a:rPr lang="en-US" smtClean="0"/>
+              <a:rPr lang="en-US"/>
               <a:t>Third level</a:t>
             </a:r>
           </a:p>
           <a:p>
             <a:pPr lvl="3"/>
             <a:r>
-              <a:rPr lang="en-US" smtClean="0"/>
+              <a:rPr lang="en-US"/>
               <a:t>Fourth level</a:t>
             </a:r>
           </a:p>
           <a:p>
             <a:pPr lvl="4"/>
             <a:r>
-              <a:rPr lang="en-US" smtClean="0"/>
+              <a:rPr lang="en-US"/>
               <a:t>Fifth level</a:t>
             </a:r>
-            <a:endParaRPr lang="en-US"/>
           </a:p>
         </p:txBody>
       </p:sp>
@@ -3261,7 +3081,7 @@
           <a:p>
             <a:pPr lvl="0"/>
             <a:r>
-              <a:rPr lang="en-US" smtClean="0"/>
+              <a:rPr lang="en-US"/>
               <a:t>Click to edit Master text styles</a:t>
             </a:r>
           </a:p>
@@ -3317,38 +3137,37 @@
           <a:p>
             <a:pPr lvl="0"/>
             <a:r>
-              <a:rPr lang="en-US" smtClean="0"/>
+              <a:rPr lang="en-US"/>
               <a:t>Click to edit Master text styles</a:t>
             </a:r>
           </a:p>
           <a:p>
             <a:pPr lvl="1"/>
             <a:r>
-              <a:rPr lang="en-US" smtClean="0"/>
+              <a:rPr lang="en-US"/>
               <a:t>Second level</a:t>
             </a:r>
           </a:p>
           <a:p>
             <a:pPr lvl="2"/>
             <a:r>
-              <a:rPr lang="en-US" smtClean="0"/>
+              <a:rPr lang="en-US"/>
               <a:t>Third level</a:t>
             </a:r>
           </a:p>
           <a:p>
             <a:pPr lvl="3"/>
             <a:r>
-              <a:rPr lang="en-US" smtClean="0"/>
+              <a:rPr lang="en-US"/>
               <a:t>Fourth level</a:t>
             </a:r>
           </a:p>
           <a:p>
             <a:pPr lvl="4"/>
             <a:r>
-              <a:rPr lang="en-US" smtClean="0"/>
+              <a:rPr lang="en-US"/>
               <a:t>Fifth level</a:t>
             </a:r>
-            <a:endParaRPr lang="en-US"/>
           </a:p>
         </p:txBody>
       </p:sp>
@@ -3369,7 +3188,7 @@
           <a:p>
             <a:fld id="{5BCAD085-E8A6-8845-BD4E-CB4CCA059FC4}" type="datetimeFigureOut">
               <a:rPr lang="en-US" smtClean="0"/>
-              <a:t>1/27/13</a:t>
+              <a:t>4/15/2026</a:t>
             </a:fld>
             <a:endParaRPr lang="en-US"/>
           </a:p>
@@ -3463,10 +3282,9 @@
           <a:lstStyle/>
           <a:p>
             <a:r>
-              <a:rPr lang="en-US" smtClean="0"/>
+              <a:rPr lang="en-US"/>
               <a:t>Click to edit Master title style</a:t>
             </a:r>
-            <a:endParaRPr lang="en-US"/>
           </a:p>
         </p:txBody>
       </p:sp>
@@ -3487,7 +3305,7 @@
           <a:p>
             <a:fld id="{5BCAD085-E8A6-8845-BD4E-CB4CCA059FC4}" type="datetimeFigureOut">
               <a:rPr lang="en-US" smtClean="0"/>
-              <a:t>1/27/13</a:t>
+              <a:t>4/15/2026</a:t>
             </a:fld>
             <a:endParaRPr lang="en-US"/>
           </a:p>
@@ -3582,7 +3400,7 @@
           <a:p>
             <a:fld id="{5BCAD085-E8A6-8845-BD4E-CB4CCA059FC4}" type="datetimeFigureOut">
               <a:rPr lang="en-US" smtClean="0"/>
-              <a:t>1/27/13</a:t>
+              <a:t>4/15/2026</a:t>
             </a:fld>
             <a:endParaRPr lang="en-US"/>
           </a:p>
@@ -3685,10 +3503,9 @@
           </a:lstStyle>
           <a:p>
             <a:r>
-              <a:rPr lang="en-US" smtClean="0"/>
+              <a:rPr lang="en-US"/>
               <a:t>Click to edit Master title style</a:t>
             </a:r>
-            <a:endParaRPr lang="en-US"/>
           </a:p>
         </p:txBody>
       </p:sp>
@@ -3742,38 +3559,37 @@
           <a:p>
             <a:pPr lvl="0"/>
             <a:r>
-              <a:rPr lang="en-US" smtClean="0"/>
+              <a:rPr lang="en-US"/>
               <a:t>Click to edit Master text styles</a:t>
             </a:r>
           </a:p>
           <a:p>
             <a:pPr lvl="1"/>
             <a:r>
-              <a:rPr lang="en-US" smtClean="0"/>
+              <a:rPr lang="en-US"/>
               <a:t>Second level</a:t>
             </a:r>
           </a:p>
           <a:p>
             <a:pPr lvl="2"/>
             <a:r>
-              <a:rPr lang="en-US" smtClean="0"/>
+              <a:rPr lang="en-US"/>
               <a:t>Third level</a:t>
             </a:r>
           </a:p>
           <a:p>
             <a:pPr lvl="3"/>
             <a:r>
-              <a:rPr lang="en-US" smtClean="0"/>
+              <a:rPr lang="en-US"/>
               <a:t>Fourth level</a:t>
             </a:r>
           </a:p>
           <a:p>
             <a:pPr lvl="4"/>
             <a:r>
-              <a:rPr lang="en-US" smtClean="0"/>
+              <a:rPr lang="en-US"/>
               <a:t>Fifth level</a:t>
             </a:r>
-            <a:endParaRPr lang="en-US"/>
           </a:p>
         </p:txBody>
       </p:sp>
@@ -3836,7 +3652,7 @@
           <a:p>
             <a:pPr lvl="0"/>
             <a:r>
-              <a:rPr lang="en-US" smtClean="0"/>
+              <a:rPr lang="en-US"/>
               <a:t>Click to edit Master text styles</a:t>
             </a:r>
           </a:p>
@@ -3859,7 +3675,7 @@
           <a:p>
             <a:fld id="{5BCAD085-E8A6-8845-BD4E-CB4CCA059FC4}" type="datetimeFigureOut">
               <a:rPr lang="en-US" smtClean="0"/>
-              <a:t>1/27/13</a:t>
+              <a:t>4/15/2026</a:t>
             </a:fld>
             <a:endParaRPr lang="en-US"/>
           </a:p>
@@ -3962,10 +3778,9 @@
           </a:lstStyle>
           <a:p>
             <a:r>
-              <a:rPr lang="en-US" smtClean="0"/>
+              <a:rPr lang="en-US"/>
               <a:t>Click to edit Master title style</a:t>
             </a:r>
-            <a:endParaRPr lang="en-US"/>
           </a:p>
         </p:txBody>
       </p:sp>
@@ -4089,7 +3904,7 @@
           <a:p>
             <a:pPr lvl="0"/>
             <a:r>
-              <a:rPr lang="en-US" smtClean="0"/>
+              <a:rPr lang="en-US"/>
               <a:t>Click to edit Master text styles</a:t>
             </a:r>
           </a:p>
@@ -4112,7 +3927,7 @@
           <a:p>
             <a:fld id="{5BCAD085-E8A6-8845-BD4E-CB4CCA059FC4}" type="datetimeFigureOut">
               <a:rPr lang="en-US" smtClean="0"/>
-              <a:t>1/27/13</a:t>
+              <a:t>4/15/2026</a:t>
             </a:fld>
             <a:endParaRPr lang="en-US"/>
           </a:p>
@@ -4221,10 +4036,9 @@
           <a:lstStyle/>
           <a:p>
             <a:r>
-              <a:rPr lang="en-US" smtClean="0"/>
+              <a:rPr lang="en-US"/>
               <a:t>Click to edit Master title style</a:t>
             </a:r>
-            <a:endParaRPr lang="en-US"/>
           </a:p>
         </p:txBody>
       </p:sp>
@@ -4255,38 +4069,37 @@
           <a:p>
             <a:pPr lvl="0"/>
             <a:r>
-              <a:rPr lang="en-US" smtClean="0"/>
+              <a:rPr lang="en-US"/>
               <a:t>Click to edit Master text styles</a:t>
             </a:r>
           </a:p>
           <a:p>
             <a:pPr lvl="1"/>
             <a:r>
-              <a:rPr lang="en-US" smtClean="0"/>
+              <a:rPr lang="en-US"/>
               <a:t>Second level</a:t>
             </a:r>
           </a:p>
           <a:p>
             <a:pPr lvl="2"/>
             <a:r>
-              <a:rPr lang="en-US" smtClean="0"/>
+              <a:rPr lang="en-US"/>
               <a:t>Third level</a:t>
             </a:r>
           </a:p>
           <a:p>
             <a:pPr lvl="3"/>
             <a:r>
-              <a:rPr lang="en-US" smtClean="0"/>
+              <a:rPr lang="en-US"/>
               <a:t>Fourth level</a:t>
             </a:r>
           </a:p>
           <a:p>
             <a:pPr lvl="4"/>
             <a:r>
-              <a:rPr lang="en-US" smtClean="0"/>
+              <a:rPr lang="en-US"/>
               <a:t>Fifth level</a:t>
             </a:r>
-            <a:endParaRPr lang="en-US"/>
           </a:p>
         </p:txBody>
       </p:sp>
@@ -4325,7 +4138,7 @@
           <a:p>
             <a:fld id="{5BCAD085-E8A6-8845-BD4E-CB4CCA059FC4}" type="datetimeFigureOut">
               <a:rPr lang="en-US" smtClean="0"/>
-              <a:t>1/27/13</a:t>
+              <a:t>4/15/2026</a:t>
             </a:fld>
             <a:endParaRPr lang="en-US"/>
           </a:p>
@@ -4684,7 +4497,7 @@
 </file>
 
 <file path=ppt/slides/slide1.xml><?xml version="1.0" encoding="utf-8"?>
-<p:sld xmlns:a="http://schemas.openxmlformats.org/drawingml/2006/main" xmlns:p="http://schemas.openxmlformats.org/presentationml/2006/main" xmlns:r="http://schemas.openxmlformats.org/officeDocument/2006/relationships">
+<p:sld xmlns:a="http://schemas.openxmlformats.org/drawingml/2006/main" xmlns:r="http://schemas.openxmlformats.org/officeDocument/2006/relationships" xmlns:p="http://schemas.openxmlformats.org/presentationml/2006/main">
   <p:cSld>
     <p:bg>
       <p:bgPr>
@@ -4700,7 +4513,14 @@
         <p:cNvGrpSpPr/>
         <p:nvPr/>
       </p:nvGrpSpPr>
-      <p:grpSpPr/>
+      <p:grpSpPr>
+        <a:xfrm>
+          <a:off x="0" y="0"/>
+          <a:ext cx="0" cy="0"/>
+          <a:chOff x="0" y="0"/>
+          <a:chExt cx="0" cy="0"/>
+        </a:xfrm>
+      </p:grpSpPr>
       <p:cxnSp>
         <p:nvCxnSpPr>
           <p:cNvPr id="2" name="Connector 1"/>
@@ -4776,6 +4596,7 @@
           <a:lstStyle/>
           <a:p>
             <a:pPr algn="ctr"/>
+            <a:endParaRPr/>
           </a:p>
         </p:txBody>
       </p:sp>
@@ -4889,6 +4710,7 @@
           <a:lstStyle/>
           <a:p>
             <a:pPr algn="ctr"/>
+            <a:endParaRPr/>
           </a:p>
         </p:txBody>
       </p:sp>
@@ -5199,7 +5021,7 @@
 </file>
 
 <file path=ppt/slides/slide10.xml><?xml version="1.0" encoding="utf-8"?>
-<p:sld xmlns:a="http://schemas.openxmlformats.org/drawingml/2006/main" xmlns:p="http://schemas.openxmlformats.org/presentationml/2006/main" xmlns:r="http://schemas.openxmlformats.org/officeDocument/2006/relationships">
+<p:sld xmlns:a="http://schemas.openxmlformats.org/drawingml/2006/main" xmlns:r="http://schemas.openxmlformats.org/officeDocument/2006/relationships" xmlns:p="http://schemas.openxmlformats.org/presentationml/2006/main">
   <p:cSld>
     <p:bg>
       <p:bgPr>
@@ -5215,7 +5037,14 @@
         <p:cNvGrpSpPr/>
         <p:nvPr/>
       </p:nvGrpSpPr>
-      <p:grpSpPr/>
+      <p:grpSpPr>
+        <a:xfrm>
+          <a:off x="0" y="0"/>
+          <a:ext cx="0" cy="0"/>
+          <a:chOff x="0" y="0"/>
+          <a:chExt cx="0" cy="0"/>
+        </a:xfrm>
+      </p:grpSpPr>
       <p:sp>
         <p:nvSpPr>
           <p:cNvPr id="2" name="Rectangle 1"/>
@@ -5256,6 +5085,7 @@
           <a:lstStyle/>
           <a:p>
             <a:pPr algn="ctr"/>
+            <a:endParaRPr/>
           </a:p>
         </p:txBody>
       </p:sp>
@@ -5389,7 +5219,7 @@
           </a:fontRef>
         </p:style>
         <p:txBody>
-          <a:bodyPr rtlCol="0" anchor="ctr" wrap="square"/>
+          <a:bodyPr wrap="square" rtlCol="0" anchor="ctr"/>
           <a:lstStyle/>
           <a:p>
             <a:pPr algn="ctr">
@@ -5463,7 +5293,7 @@
           </a:fontRef>
         </p:style>
         <p:txBody>
-          <a:bodyPr rtlCol="0" anchor="ctr" wrap="square"/>
+          <a:bodyPr wrap="square" rtlCol="0" anchor="ctr"/>
           <a:lstStyle/>
           <a:p>
             <a:pPr algn="ctr">
@@ -5537,7 +5367,7 @@
           </a:fontRef>
         </p:style>
         <p:txBody>
-          <a:bodyPr rtlCol="0" anchor="ctr" wrap="square"/>
+          <a:bodyPr wrap="square" rtlCol="0" anchor="ctr"/>
           <a:lstStyle/>
           <a:p>
             <a:pPr algn="ctr">
@@ -5611,7 +5441,7 @@
           </a:fontRef>
         </p:style>
         <p:txBody>
-          <a:bodyPr rtlCol="0" anchor="ctr" wrap="square"/>
+          <a:bodyPr wrap="square" rtlCol="0" anchor="ctr"/>
           <a:lstStyle/>
           <a:p>
             <a:pPr algn="l">
@@ -5640,7 +5470,7 @@
           <p:nvPr/>
         </p:nvPicPr>
         <p:blipFill>
-          <a:blip r:embed="rId4"/>
+          <a:blip r:embed="rId3"/>
           <a:stretch>
             <a:fillRect/>
           </a:stretch>
@@ -5700,7 +5530,7 @@
 </file>
 
 <file path=ppt/slides/slide11.xml><?xml version="1.0" encoding="utf-8"?>
-<p:sld xmlns:a="http://schemas.openxmlformats.org/drawingml/2006/main" xmlns:p="http://schemas.openxmlformats.org/presentationml/2006/main" xmlns:r="http://schemas.openxmlformats.org/officeDocument/2006/relationships">
+<p:sld xmlns:a="http://schemas.openxmlformats.org/drawingml/2006/main" xmlns:r="http://schemas.openxmlformats.org/officeDocument/2006/relationships" xmlns:p="http://schemas.openxmlformats.org/presentationml/2006/main">
   <p:cSld>
     <p:bg>
       <p:bgPr>
@@ -5716,7 +5546,14 @@
         <p:cNvGrpSpPr/>
         <p:nvPr/>
       </p:nvGrpSpPr>
-      <p:grpSpPr/>
+      <p:grpSpPr>
+        <a:xfrm>
+          <a:off x="0" y="0"/>
+          <a:ext cx="0" cy="0"/>
+          <a:chOff x="0" y="0"/>
+          <a:chExt cx="0" cy="0"/>
+        </a:xfrm>
+      </p:grpSpPr>
       <p:sp>
         <p:nvSpPr>
           <p:cNvPr id="2" name="Rectangle 1"/>
@@ -5757,6 +5594,7 @@
           <a:lstStyle/>
           <a:p>
             <a:pPr algn="ctr"/>
+            <a:endParaRPr/>
           </a:p>
         </p:txBody>
       </p:sp>
@@ -5796,7 +5634,7 @@
           </a:fontRef>
         </p:style>
         <p:txBody>
-          <a:bodyPr rtlCol="0" anchor="ctr" wrap="square"/>
+          <a:bodyPr wrap="square" rtlCol="0" anchor="ctr"/>
           <a:lstStyle/>
           <a:p>
             <a:pPr algn="ctr">
@@ -5890,7 +5728,7 @@
           </a:fontRef>
         </p:style>
         <p:txBody>
-          <a:bodyPr rtlCol="0" anchor="ctr" wrap="square"/>
+          <a:bodyPr wrap="square" rtlCol="0" anchor="ctr"/>
           <a:lstStyle/>
           <a:p>
             <a:pPr algn="l">
@@ -6012,7 +5850,7 @@
           </a:fontRef>
         </p:style>
         <p:txBody>
-          <a:bodyPr rtlCol="0" anchor="ctr" wrap="square"/>
+          <a:bodyPr wrap="square" rtlCol="0" anchor="ctr"/>
           <a:lstStyle/>
           <a:p>
             <a:pPr algn="l">
@@ -6166,7 +6004,7 @@
           </a:fontRef>
         </p:style>
         <p:txBody>
-          <a:bodyPr rtlCol="0" anchor="ctr" wrap="square"/>
+          <a:bodyPr wrap="square" rtlCol="0" anchor="ctr"/>
           <a:lstStyle/>
           <a:p>
             <a:pPr algn="l">
@@ -6298,7 +6136,7 @@
 </file>
 
 <file path=ppt/slides/slide12.xml><?xml version="1.0" encoding="utf-8"?>
-<p:sld xmlns:a="http://schemas.openxmlformats.org/drawingml/2006/main" xmlns:p="http://schemas.openxmlformats.org/presentationml/2006/main" xmlns:r="http://schemas.openxmlformats.org/officeDocument/2006/relationships">
+<p:sld xmlns:a="http://schemas.openxmlformats.org/drawingml/2006/main" xmlns:r="http://schemas.openxmlformats.org/officeDocument/2006/relationships" xmlns:p="http://schemas.openxmlformats.org/presentationml/2006/main">
   <p:cSld>
     <p:bg>
       <p:bgPr>
@@ -6314,7 +6152,14 @@
         <p:cNvGrpSpPr/>
         <p:nvPr/>
       </p:nvGrpSpPr>
-      <p:grpSpPr/>
+      <p:grpSpPr>
+        <a:xfrm>
+          <a:off x="0" y="0"/>
+          <a:ext cx="0" cy="0"/>
+          <a:chOff x="0" y="0"/>
+          <a:chExt cx="0" cy="0"/>
+        </a:xfrm>
+      </p:grpSpPr>
       <p:sp>
         <p:nvSpPr>
           <p:cNvPr id="2" name="Rectangle 1"/>
@@ -6355,6 +6200,7 @@
           <a:lstStyle/>
           <a:p>
             <a:pPr algn="ctr"/>
+            <a:endParaRPr/>
           </a:p>
         </p:txBody>
       </p:sp>
@@ -6394,7 +6240,7 @@
           </a:fontRef>
         </p:style>
         <p:txBody>
-          <a:bodyPr rtlCol="0" anchor="ctr" wrap="square"/>
+          <a:bodyPr wrap="square" rtlCol="0" anchor="ctr"/>
           <a:lstStyle/>
           <a:p>
             <a:pPr algn="ctr">
@@ -6488,7 +6334,7 @@
           </a:fontRef>
         </p:style>
         <p:txBody>
-          <a:bodyPr rtlCol="0" anchor="ctr" wrap="square"/>
+          <a:bodyPr wrap="square" rtlCol="0" anchor="ctr"/>
           <a:lstStyle/>
           <a:p>
             <a:pPr algn="ctr">
@@ -6594,7 +6440,7 @@
           </a:fontRef>
         </p:style>
         <p:txBody>
-          <a:bodyPr rtlCol="0" anchor="ctr" wrap="square"/>
+          <a:bodyPr wrap="square" rtlCol="0" anchor="ctr"/>
           <a:lstStyle/>
           <a:p>
             <a:pPr algn="ctr">
@@ -6700,7 +6546,7 @@
           </a:fontRef>
         </p:style>
         <p:txBody>
-          <a:bodyPr rtlCol="0" anchor="ctr" wrap="square"/>
+          <a:bodyPr wrap="square" rtlCol="0" anchor="ctr"/>
           <a:lstStyle/>
           <a:p>
             <a:pPr algn="ctr">
@@ -6806,7 +6652,7 @@
           </a:fontRef>
         </p:style>
         <p:txBody>
-          <a:bodyPr rtlCol="0" anchor="ctr" wrap="square"/>
+          <a:bodyPr wrap="square" rtlCol="0" anchor="ctr"/>
           <a:lstStyle/>
           <a:p>
             <a:pPr algn="ctr">
@@ -6965,7 +6811,7 @@
 </file>
 
 <file path=ppt/slides/slide13.xml><?xml version="1.0" encoding="utf-8"?>
-<p:sld xmlns:a="http://schemas.openxmlformats.org/drawingml/2006/main" xmlns:p="http://schemas.openxmlformats.org/presentationml/2006/main" xmlns:r="http://schemas.openxmlformats.org/officeDocument/2006/relationships">
+<p:sld xmlns:a="http://schemas.openxmlformats.org/drawingml/2006/main" xmlns:r="http://schemas.openxmlformats.org/officeDocument/2006/relationships" xmlns:p="http://schemas.openxmlformats.org/presentationml/2006/main">
   <p:cSld>
     <p:bg>
       <p:bgPr>
@@ -6981,7 +6827,14 @@
         <p:cNvGrpSpPr/>
         <p:nvPr/>
       </p:nvGrpSpPr>
-      <p:grpSpPr/>
+      <p:grpSpPr>
+        <a:xfrm>
+          <a:off x="0" y="0"/>
+          <a:ext cx="0" cy="0"/>
+          <a:chOff x="0" y="0"/>
+          <a:chExt cx="0" cy="0"/>
+        </a:xfrm>
+      </p:grpSpPr>
       <p:sp>
         <p:nvSpPr>
           <p:cNvPr id="2" name="Rectangle 1"/>
@@ -7022,6 +6875,7 @@
           <a:lstStyle/>
           <a:p>
             <a:pPr algn="ctr"/>
+            <a:endParaRPr/>
           </a:p>
         </p:txBody>
       </p:sp>
@@ -7061,7 +6915,7 @@
           </a:fontRef>
         </p:style>
         <p:txBody>
-          <a:bodyPr rtlCol="0" anchor="ctr" wrap="square"/>
+          <a:bodyPr wrap="square" rtlCol="0" anchor="ctr"/>
           <a:lstStyle/>
           <a:p>
             <a:pPr algn="ctr">
@@ -7155,7 +7009,7 @@
           </a:fontRef>
         </p:style>
         <p:txBody>
-          <a:bodyPr rtlCol="0" anchor="ctr" wrap="square"/>
+          <a:bodyPr wrap="square" rtlCol="0" anchor="ctr"/>
           <a:lstStyle/>
           <a:p>
             <a:pPr algn="ctr">
@@ -7277,7 +7131,7 @@
           </a:fontRef>
         </p:style>
         <p:txBody>
-          <a:bodyPr rtlCol="0" anchor="ctr" wrap="square"/>
+          <a:bodyPr wrap="square" rtlCol="0" anchor="ctr"/>
           <a:lstStyle/>
           <a:p>
             <a:pPr algn="ctr">
@@ -7399,7 +7253,7 @@
           </a:fontRef>
         </p:style>
         <p:txBody>
-          <a:bodyPr rtlCol="0" anchor="ctr" wrap="square"/>
+          <a:bodyPr wrap="square" rtlCol="0" anchor="ctr"/>
           <a:lstStyle/>
           <a:p>
             <a:pPr algn="ctr">
@@ -7521,7 +7375,7 @@
           </a:fontRef>
         </p:style>
         <p:txBody>
-          <a:bodyPr rtlCol="0" anchor="ctr" wrap="square"/>
+          <a:bodyPr wrap="square" rtlCol="0" anchor="ctr"/>
           <a:lstStyle/>
           <a:p>
             <a:pPr algn="ctr">
@@ -7653,7 +7507,7 @@
 </file>
 
 <file path=ppt/slides/slide14.xml><?xml version="1.0" encoding="utf-8"?>
-<p:sld xmlns:a="http://schemas.openxmlformats.org/drawingml/2006/main" xmlns:p="http://schemas.openxmlformats.org/presentationml/2006/main" xmlns:r="http://schemas.openxmlformats.org/officeDocument/2006/relationships">
+<p:sld xmlns:a="http://schemas.openxmlformats.org/drawingml/2006/main" xmlns:r="http://schemas.openxmlformats.org/officeDocument/2006/relationships" xmlns:p="http://schemas.openxmlformats.org/presentationml/2006/main">
   <p:cSld>
     <p:bg>
       <p:bgPr>
@@ -7669,7 +7523,14 @@
         <p:cNvGrpSpPr/>
         <p:nvPr/>
       </p:nvGrpSpPr>
-      <p:grpSpPr/>
+      <p:grpSpPr>
+        <a:xfrm>
+          <a:off x="0" y="0"/>
+          <a:ext cx="0" cy="0"/>
+          <a:chOff x="0" y="0"/>
+          <a:chExt cx="0" cy="0"/>
+        </a:xfrm>
+      </p:grpSpPr>
       <p:sp>
         <p:nvSpPr>
           <p:cNvPr id="2" name="Rectangle 1"/>
@@ -7710,6 +7571,7 @@
           <a:lstStyle/>
           <a:p>
             <a:pPr algn="ctr"/>
+            <a:endParaRPr/>
           </a:p>
         </p:txBody>
       </p:sp>
@@ -8407,7 +8269,7 @@
           </a:fontRef>
         </p:style>
         <p:txBody>
-          <a:bodyPr rtlCol="0" anchor="ctr" wrap="square"/>
+          <a:bodyPr wrap="square" rtlCol="0" anchor="ctr"/>
           <a:lstStyle/>
           <a:p>
             <a:pPr algn="l">
@@ -8488,7 +8350,7 @@
 </file>
 
 <file path=ppt/slides/slide15.xml><?xml version="1.0" encoding="utf-8"?>
-<p:sld xmlns:a="http://schemas.openxmlformats.org/drawingml/2006/main" xmlns:p="http://schemas.openxmlformats.org/presentationml/2006/main" xmlns:r="http://schemas.openxmlformats.org/officeDocument/2006/relationships">
+<p:sld xmlns:a="http://schemas.openxmlformats.org/drawingml/2006/main" xmlns:r="http://schemas.openxmlformats.org/officeDocument/2006/relationships" xmlns:p="http://schemas.openxmlformats.org/presentationml/2006/main">
   <p:cSld>
     <p:bg>
       <p:bgPr>
@@ -8504,7 +8366,14 @@
         <p:cNvGrpSpPr/>
         <p:nvPr/>
       </p:nvGrpSpPr>
-      <p:grpSpPr/>
+      <p:grpSpPr>
+        <a:xfrm>
+          <a:off x="0" y="0"/>
+          <a:ext cx="0" cy="0"/>
+          <a:chOff x="0" y="0"/>
+          <a:chExt cx="0" cy="0"/>
+        </a:xfrm>
+      </p:grpSpPr>
       <p:cxnSp>
         <p:nvCxnSpPr>
           <p:cNvPr id="2" name="Connector 1"/>
@@ -8580,6 +8449,7 @@
           <a:lstStyle/>
           <a:p>
             <a:pPr algn="ctr"/>
+            <a:endParaRPr/>
           </a:p>
         </p:txBody>
       </p:sp>
@@ -8658,6 +8528,7 @@
           <a:lstStyle/>
           <a:p>
             <a:pPr algn="ctr"/>
+            <a:endParaRPr/>
           </a:p>
         </p:txBody>
       </p:sp>
@@ -8760,7 +8631,9 @@
             <a:spAutoFit/>
           </a:bodyPr>
           <a:lstStyle/>
-          <a:p/>
+          <a:p>
+            <a:endParaRPr/>
+          </a:p>
           <a:p>
             <a:pPr>
               <a:spcAft>
@@ -8897,7 +8770,7 @@
           </a:fontRef>
         </p:style>
         <p:txBody>
-          <a:bodyPr rtlCol="0" anchor="ctr" wrap="square"/>
+          <a:bodyPr wrap="square" rtlCol="0" anchor="ctr"/>
           <a:lstStyle/>
           <a:p>
             <a:pPr algn="ctr">
@@ -8965,7 +8838,7 @@
           </a:fontRef>
         </p:style>
         <p:txBody>
-          <a:bodyPr rtlCol="0" anchor="ctr" wrap="square"/>
+          <a:bodyPr wrap="square" rtlCol="0" anchor="ctr"/>
           <a:lstStyle/>
           <a:p>
             <a:pPr algn="ctr">
@@ -9033,7 +8906,7 @@
           </a:fontRef>
         </p:style>
         <p:txBody>
-          <a:bodyPr rtlCol="0" anchor="ctr" wrap="square"/>
+          <a:bodyPr wrap="square" rtlCol="0" anchor="ctr"/>
           <a:lstStyle/>
           <a:p>
             <a:pPr algn="ctr">
@@ -9101,7 +8974,7 @@
           </a:fontRef>
         </p:style>
         <p:txBody>
-          <a:bodyPr rtlCol="0" anchor="ctr" wrap="square"/>
+          <a:bodyPr wrap="square" rtlCol="0" anchor="ctr"/>
           <a:lstStyle/>
           <a:p>
             <a:pPr algn="l">
@@ -9169,7 +9042,7 @@
 </file>
 
 <file path=ppt/slides/slide16.xml><?xml version="1.0" encoding="utf-8"?>
-<p:sld xmlns:a="http://schemas.openxmlformats.org/drawingml/2006/main" xmlns:p="http://schemas.openxmlformats.org/presentationml/2006/main" xmlns:r="http://schemas.openxmlformats.org/officeDocument/2006/relationships">
+<p:sld xmlns:a="http://schemas.openxmlformats.org/drawingml/2006/main" xmlns:r="http://schemas.openxmlformats.org/officeDocument/2006/relationships" xmlns:p="http://schemas.openxmlformats.org/presentationml/2006/main">
   <p:cSld>
     <p:bg>
       <p:bgPr>
@@ -9185,7 +9058,14 @@
         <p:cNvGrpSpPr/>
         <p:nvPr/>
       </p:nvGrpSpPr>
-      <p:grpSpPr/>
+      <p:grpSpPr>
+        <a:xfrm>
+          <a:off x="0" y="0"/>
+          <a:ext cx="0" cy="0"/>
+          <a:chOff x="0" y="0"/>
+          <a:chExt cx="0" cy="0"/>
+        </a:xfrm>
+      </p:grpSpPr>
       <p:cxnSp>
         <p:nvCxnSpPr>
           <p:cNvPr id="2" name="Connector 1"/>
@@ -9261,6 +9141,7 @@
           <a:lstStyle/>
           <a:p>
             <a:pPr algn="ctr"/>
+            <a:endParaRPr/>
           </a:p>
         </p:txBody>
       </p:sp>
@@ -9339,6 +9220,7 @@
           <a:lstStyle/>
           <a:p>
             <a:pPr algn="ctr"/>
+            <a:endParaRPr/>
           </a:p>
         </p:txBody>
       </p:sp>
@@ -9590,7 +9472,7 @@
 </file>
 
 <file path=ppt/slides/slide2.xml><?xml version="1.0" encoding="utf-8"?>
-<p:sld xmlns:a="http://schemas.openxmlformats.org/drawingml/2006/main" xmlns:p="http://schemas.openxmlformats.org/presentationml/2006/main" xmlns:r="http://schemas.openxmlformats.org/officeDocument/2006/relationships">
+<p:sld xmlns:a="http://schemas.openxmlformats.org/drawingml/2006/main" xmlns:r="http://schemas.openxmlformats.org/officeDocument/2006/relationships" xmlns:p="http://schemas.openxmlformats.org/presentationml/2006/main">
   <p:cSld>
     <p:bg>
       <p:bgPr>
@@ -9606,7 +9488,14 @@
         <p:cNvGrpSpPr/>
         <p:nvPr/>
       </p:nvGrpSpPr>
-      <p:grpSpPr/>
+      <p:grpSpPr>
+        <a:xfrm>
+          <a:off x="0" y="0"/>
+          <a:ext cx="0" cy="0"/>
+          <a:chOff x="0" y="0"/>
+          <a:chExt cx="0" cy="0"/>
+        </a:xfrm>
+      </p:grpSpPr>
       <p:sp>
         <p:nvSpPr>
           <p:cNvPr id="2" name="Rectangle 1"/>
@@ -9647,6 +9536,7 @@
           <a:lstStyle/>
           <a:p>
             <a:pPr algn="ctr"/>
+            <a:endParaRPr/>
           </a:p>
         </p:txBody>
       </p:sp>
@@ -9686,7 +9576,7 @@
           </a:fontRef>
         </p:style>
         <p:txBody>
-          <a:bodyPr rtlCol="0" anchor="ctr" wrap="square"/>
+          <a:bodyPr wrap="square" rtlCol="0" anchor="ctr"/>
           <a:lstStyle/>
           <a:p>
             <a:pPr algn="ctr">
@@ -9915,7 +9805,7 @@
           </a:fontRef>
         </p:style>
         <p:txBody>
-          <a:bodyPr rtlCol="0" anchor="ctr" wrap="square"/>
+          <a:bodyPr wrap="square" rtlCol="0" anchor="ctr"/>
           <a:lstStyle/>
           <a:p>
             <a:pPr algn="ctr">
@@ -10143,7 +10033,7 @@
 </file>
 
 <file path=ppt/slides/slide3.xml><?xml version="1.0" encoding="utf-8"?>
-<p:sld xmlns:a="http://schemas.openxmlformats.org/drawingml/2006/main" xmlns:p="http://schemas.openxmlformats.org/presentationml/2006/main" xmlns:r="http://schemas.openxmlformats.org/officeDocument/2006/relationships">
+<p:sld xmlns:a="http://schemas.openxmlformats.org/drawingml/2006/main" xmlns:r="http://schemas.openxmlformats.org/officeDocument/2006/relationships" xmlns:p="http://schemas.openxmlformats.org/presentationml/2006/main">
   <p:cSld>
     <p:bg>
       <p:bgPr>
@@ -10159,7 +10049,14 @@
         <p:cNvGrpSpPr/>
         <p:nvPr/>
       </p:nvGrpSpPr>
-      <p:grpSpPr/>
+      <p:grpSpPr>
+        <a:xfrm>
+          <a:off x="0" y="0"/>
+          <a:ext cx="0" cy="0"/>
+          <a:chOff x="0" y="0"/>
+          <a:chExt cx="0" cy="0"/>
+        </a:xfrm>
+      </p:grpSpPr>
       <p:sp>
         <p:nvSpPr>
           <p:cNvPr id="2" name="Rectangle 1"/>
@@ -10200,6 +10097,7 @@
           <a:lstStyle/>
           <a:p>
             <a:pPr algn="ctr"/>
+            <a:endParaRPr/>
           </a:p>
         </p:txBody>
       </p:sp>
@@ -10514,7 +10412,7 @@
 </file>
 
 <file path=ppt/slides/slide4.xml><?xml version="1.0" encoding="utf-8"?>
-<p:sld xmlns:a="http://schemas.openxmlformats.org/drawingml/2006/main" xmlns:p="http://schemas.openxmlformats.org/presentationml/2006/main" xmlns:r="http://schemas.openxmlformats.org/officeDocument/2006/relationships">
+<p:sld xmlns:a="http://schemas.openxmlformats.org/drawingml/2006/main" xmlns:r="http://schemas.openxmlformats.org/officeDocument/2006/relationships" xmlns:p="http://schemas.openxmlformats.org/presentationml/2006/main">
   <p:cSld>
     <p:bg>
       <p:bgPr>
@@ -10530,7 +10428,14 @@
         <p:cNvGrpSpPr/>
         <p:nvPr/>
       </p:nvGrpSpPr>
-      <p:grpSpPr/>
+      <p:grpSpPr>
+        <a:xfrm>
+          <a:off x="0" y="0"/>
+          <a:ext cx="0" cy="0"/>
+          <a:chOff x="0" y="0"/>
+          <a:chExt cx="0" cy="0"/>
+        </a:xfrm>
+      </p:grpSpPr>
       <p:sp>
         <p:nvSpPr>
           <p:cNvPr id="2" name="Rectangle 1"/>
@@ -10571,6 +10476,7 @@
           <a:lstStyle/>
           <a:p>
             <a:pPr algn="ctr"/>
+            <a:endParaRPr/>
           </a:p>
         </p:txBody>
       </p:sp>
@@ -10610,7 +10516,7 @@
           </a:fontRef>
         </p:style>
         <p:txBody>
-          <a:bodyPr rtlCol="0" anchor="ctr" wrap="square"/>
+          <a:bodyPr wrap="square" rtlCol="0" anchor="ctr"/>
           <a:lstStyle/>
           <a:p>
             <a:pPr algn="ctr">
@@ -10704,7 +10610,7 @@
           </a:fontRef>
         </p:style>
         <p:txBody>
-          <a:bodyPr rtlCol="0" anchor="ctr" wrap="square"/>
+          <a:bodyPr wrap="square" rtlCol="0" anchor="ctr"/>
           <a:lstStyle/>
           <a:p>
             <a:pPr algn="l">
@@ -10778,7 +10684,7 @@
           </a:fontRef>
         </p:style>
         <p:txBody>
-          <a:bodyPr rtlCol="0" anchor="ctr" wrap="square"/>
+          <a:bodyPr wrap="square" rtlCol="0" anchor="ctr"/>
           <a:lstStyle/>
           <a:p>
             <a:pPr algn="ctr">
@@ -10866,7 +10772,7 @@
           </a:fontRef>
         </p:style>
         <p:txBody>
-          <a:bodyPr rtlCol="0" anchor="ctr" wrap="square"/>
+          <a:bodyPr wrap="square" rtlCol="0" anchor="ctr"/>
           <a:lstStyle/>
           <a:p>
             <a:pPr algn="ctr">
@@ -10954,7 +10860,7 @@
           </a:fontRef>
         </p:style>
         <p:txBody>
-          <a:bodyPr rtlCol="0" anchor="ctr" wrap="square"/>
+          <a:bodyPr wrap="square" rtlCol="0" anchor="ctr"/>
           <a:lstStyle/>
           <a:p>
             <a:pPr algn="ctr">
@@ -11091,7 +10997,7 @@
 </file>
 
 <file path=ppt/slides/slide5.xml><?xml version="1.0" encoding="utf-8"?>
-<p:sld xmlns:a="http://schemas.openxmlformats.org/drawingml/2006/main" xmlns:p="http://schemas.openxmlformats.org/presentationml/2006/main" xmlns:r="http://schemas.openxmlformats.org/officeDocument/2006/relationships">
+<p:sld xmlns:a="http://schemas.openxmlformats.org/drawingml/2006/main" xmlns:r="http://schemas.openxmlformats.org/officeDocument/2006/relationships" xmlns:p="http://schemas.openxmlformats.org/presentationml/2006/main">
   <p:cSld>
     <p:bg>
       <p:bgPr>
@@ -11107,7 +11013,14 @@
         <p:cNvGrpSpPr/>
         <p:nvPr/>
       </p:nvGrpSpPr>
-      <p:grpSpPr/>
+      <p:grpSpPr>
+        <a:xfrm>
+          <a:off x="0" y="0"/>
+          <a:ext cx="0" cy="0"/>
+          <a:chOff x="0" y="0"/>
+          <a:chExt cx="0" cy="0"/>
+        </a:xfrm>
+      </p:grpSpPr>
       <p:sp>
         <p:nvSpPr>
           <p:cNvPr id="2" name="Rectangle 1"/>
@@ -11148,6 +11061,7 @@
           <a:lstStyle/>
           <a:p>
             <a:pPr algn="ctr"/>
+            <a:endParaRPr/>
           </a:p>
         </p:txBody>
       </p:sp>
@@ -11281,7 +11195,7 @@
           </a:fontRef>
         </p:style>
         <p:txBody>
-          <a:bodyPr rtlCol="0" anchor="ctr" wrap="square"/>
+          <a:bodyPr wrap="square" rtlCol="0" anchor="ctr"/>
           <a:lstStyle/>
           <a:p>
             <a:pPr algn="l">
@@ -11493,8 +11407,8 @@
         </p:blipFill>
         <p:spPr>
           <a:xfrm>
-            <a:off x="6400800" y="1828800"/>
-            <a:ext cx="5303520" cy="4481785"/>
+            <a:off x="5394346" y="1141466"/>
+            <a:ext cx="6549313" cy="4481785"/>
           </a:xfrm>
           <a:prstGeom prst="rect">
             <a:avLst/>
@@ -11539,7 +11453,7 @@
           </a:fontRef>
         </p:style>
         <p:txBody>
-          <a:bodyPr rtlCol="0" anchor="ctr" wrap="square"/>
+          <a:bodyPr wrap="square" rtlCol="0" anchor="ctr"/>
           <a:lstStyle/>
           <a:p>
             <a:pPr algn="ctr"/>
@@ -11602,7 +11516,7 @@
           </a:fontRef>
         </p:style>
         <p:txBody>
-          <a:bodyPr rtlCol="0" anchor="ctr" wrap="square"/>
+          <a:bodyPr wrap="square" rtlCol="0" anchor="ctr"/>
           <a:lstStyle/>
           <a:p>
             <a:pPr algn="ctr"/>
@@ -11665,7 +11579,7 @@
           </a:fontRef>
         </p:style>
         <p:txBody>
-          <a:bodyPr rtlCol="0" anchor="ctr" wrap="square"/>
+          <a:bodyPr wrap="square" rtlCol="0" anchor="ctr"/>
           <a:lstStyle/>
           <a:p>
             <a:pPr algn="ctr"/>
@@ -11728,7 +11642,7 @@
           </a:fontRef>
         </p:style>
         <p:txBody>
-          <a:bodyPr rtlCol="0" anchor="ctr" wrap="square"/>
+          <a:bodyPr wrap="square" rtlCol="0" anchor="ctr"/>
           <a:lstStyle/>
           <a:p>
             <a:pPr algn="ctr"/>
@@ -11798,7 +11712,7 @@
 </file>
 
 <file path=ppt/slides/slide6.xml><?xml version="1.0" encoding="utf-8"?>
-<p:sld xmlns:a="http://schemas.openxmlformats.org/drawingml/2006/main" xmlns:p="http://schemas.openxmlformats.org/presentationml/2006/main" xmlns:r="http://schemas.openxmlformats.org/officeDocument/2006/relationships">
+<p:sld xmlns:a="http://schemas.openxmlformats.org/drawingml/2006/main" xmlns:r="http://schemas.openxmlformats.org/officeDocument/2006/relationships" xmlns:p="http://schemas.openxmlformats.org/presentationml/2006/main">
   <p:cSld>
     <p:bg>
       <p:bgPr>
@@ -11814,7 +11728,14 @@
         <p:cNvGrpSpPr/>
         <p:nvPr/>
       </p:nvGrpSpPr>
-      <p:grpSpPr/>
+      <p:grpSpPr>
+        <a:xfrm>
+          <a:off x="0" y="0"/>
+          <a:ext cx="0" cy="0"/>
+          <a:chOff x="0" y="0"/>
+          <a:chExt cx="0" cy="0"/>
+        </a:xfrm>
+      </p:grpSpPr>
       <p:sp>
         <p:nvSpPr>
           <p:cNvPr id="2" name="Rectangle 1"/>
@@ -11855,6 +11776,7 @@
           <a:lstStyle/>
           <a:p>
             <a:pPr algn="ctr"/>
+            <a:endParaRPr/>
           </a:p>
         </p:txBody>
       </p:sp>
@@ -11894,7 +11816,7 @@
           </a:fontRef>
         </p:style>
         <p:txBody>
-          <a:bodyPr rtlCol="0" anchor="ctr" wrap="square"/>
+          <a:bodyPr wrap="square" rtlCol="0" anchor="ctr"/>
           <a:lstStyle/>
           <a:p>
             <a:pPr algn="ctr">
@@ -12186,7 +12108,7 @@
           </a:fontRef>
         </p:style>
         <p:txBody>
-          <a:bodyPr rtlCol="0" anchor="ctr" wrap="square"/>
+          <a:bodyPr wrap="square" rtlCol="0" anchor="ctr"/>
           <a:lstStyle/>
           <a:p>
             <a:pPr algn="l">
@@ -12446,7 +12368,7 @@
 </file>
 
 <file path=ppt/slides/slide7.xml><?xml version="1.0" encoding="utf-8"?>
-<p:sld xmlns:a="http://schemas.openxmlformats.org/drawingml/2006/main" xmlns:p="http://schemas.openxmlformats.org/presentationml/2006/main" xmlns:r="http://schemas.openxmlformats.org/officeDocument/2006/relationships">
+<p:sld xmlns:a="http://schemas.openxmlformats.org/drawingml/2006/main" xmlns:r="http://schemas.openxmlformats.org/officeDocument/2006/relationships" xmlns:p="http://schemas.openxmlformats.org/presentationml/2006/main">
   <p:cSld>
     <p:bg>
       <p:bgPr>
@@ -12462,7 +12384,14 @@
         <p:cNvGrpSpPr/>
         <p:nvPr/>
       </p:nvGrpSpPr>
-      <p:grpSpPr/>
+      <p:grpSpPr>
+        <a:xfrm>
+          <a:off x="0" y="0"/>
+          <a:ext cx="0" cy="0"/>
+          <a:chOff x="0" y="0"/>
+          <a:chExt cx="0" cy="0"/>
+        </a:xfrm>
+      </p:grpSpPr>
       <p:sp>
         <p:nvSpPr>
           <p:cNvPr id="2" name="Rectangle 1"/>
@@ -12503,6 +12432,7 @@
           <a:lstStyle/>
           <a:p>
             <a:pPr algn="ctr"/>
+            <a:endParaRPr/>
           </a:p>
         </p:txBody>
       </p:sp>
@@ -12636,7 +12566,7 @@
           </a:fontRef>
         </p:style>
         <p:txBody>
-          <a:bodyPr rtlCol="0" anchor="ctr" wrap="square"/>
+          <a:bodyPr wrap="square" rtlCol="0" anchor="ctr"/>
           <a:lstStyle/>
           <a:p>
             <a:pPr algn="ctr">
@@ -12712,7 +12642,7 @@
           </a:fontRef>
         </p:style>
         <p:txBody>
-          <a:bodyPr rtlCol="0" anchor="ctr" wrap="square"/>
+          <a:bodyPr wrap="square" rtlCol="0" anchor="ctr"/>
           <a:lstStyle/>
           <a:p>
             <a:pPr algn="ctr">
@@ -12788,7 +12718,7 @@
           </a:fontRef>
         </p:style>
         <p:txBody>
-          <a:bodyPr rtlCol="0" anchor="ctr" wrap="square"/>
+          <a:bodyPr wrap="square" rtlCol="0" anchor="ctr"/>
           <a:lstStyle/>
           <a:p>
             <a:pPr algn="ctr">
@@ -12938,7 +12868,7 @@
           </a:fontRef>
         </p:style>
         <p:txBody>
-          <a:bodyPr rtlCol="0" anchor="ctr" wrap="square"/>
+          <a:bodyPr wrap="square" rtlCol="0" anchor="ctr"/>
           <a:lstStyle/>
           <a:p>
             <a:pPr algn="l">
@@ -13028,7 +12958,7 @@
           </a:fontRef>
         </p:style>
         <p:txBody>
-          <a:bodyPr rtlCol="0" anchor="ctr" wrap="square"/>
+          <a:bodyPr wrap="square" rtlCol="0" anchor="ctr"/>
           <a:lstStyle/>
           <a:p>
             <a:pPr algn="ctr">
@@ -13099,7 +13029,7 @@
           </a:fontRef>
         </p:style>
         <p:txBody>
-          <a:bodyPr rtlCol="0" anchor="ctr" wrap="square"/>
+          <a:bodyPr wrap="square" rtlCol="0" anchor="ctr"/>
           <a:lstStyle/>
           <a:p>
             <a:pPr algn="ctr">
@@ -13170,7 +13100,7 @@
           </a:fontRef>
         </p:style>
         <p:txBody>
-          <a:bodyPr rtlCol="0" anchor="ctr" wrap="square"/>
+          <a:bodyPr wrap="square" rtlCol="0" anchor="ctr"/>
           <a:lstStyle/>
           <a:p>
             <a:pPr algn="ctr">
@@ -13248,7 +13178,7 @@
 </file>
 
 <file path=ppt/slides/slide8.xml><?xml version="1.0" encoding="utf-8"?>
-<p:sld xmlns:a="http://schemas.openxmlformats.org/drawingml/2006/main" xmlns:p="http://schemas.openxmlformats.org/presentationml/2006/main" xmlns:r="http://schemas.openxmlformats.org/officeDocument/2006/relationships">
+<p:sld xmlns:a="http://schemas.openxmlformats.org/drawingml/2006/main" xmlns:r="http://schemas.openxmlformats.org/officeDocument/2006/relationships" xmlns:p="http://schemas.openxmlformats.org/presentationml/2006/main">
   <p:cSld>
     <p:bg>
       <p:bgPr>
@@ -13264,7 +13194,14 @@
         <p:cNvGrpSpPr/>
         <p:nvPr/>
       </p:nvGrpSpPr>
-      <p:grpSpPr/>
+      <p:grpSpPr>
+        <a:xfrm>
+          <a:off x="0" y="0"/>
+          <a:ext cx="0" cy="0"/>
+          <a:chOff x="0" y="0"/>
+          <a:chExt cx="0" cy="0"/>
+        </a:xfrm>
+      </p:grpSpPr>
       <p:sp>
         <p:nvSpPr>
           <p:cNvPr id="2" name="Rectangle 1"/>
@@ -13305,6 +13242,7 @@
           <a:lstStyle/>
           <a:p>
             <a:pPr algn="ctr"/>
+            <a:endParaRPr/>
           </a:p>
         </p:txBody>
       </p:sp>
@@ -13438,7 +13376,7 @@
           </a:fontRef>
         </p:style>
         <p:txBody>
-          <a:bodyPr rtlCol="0" anchor="ctr" wrap="square"/>
+          <a:bodyPr wrap="square" rtlCol="0" anchor="ctr"/>
           <a:lstStyle/>
           <a:p>
             <a:pPr algn="ctr">
@@ -13506,7 +13444,7 @@
           </a:fontRef>
         </p:style>
         <p:txBody>
-          <a:bodyPr rtlCol="0" anchor="ctr" wrap="square"/>
+          <a:bodyPr wrap="square" rtlCol="0" anchor="ctr"/>
           <a:lstStyle/>
           <a:p>
             <a:pPr algn="ctr">
@@ -13574,7 +13512,7 @@
           </a:fontRef>
         </p:style>
         <p:txBody>
-          <a:bodyPr rtlCol="0" anchor="ctr" wrap="square"/>
+          <a:bodyPr wrap="square" rtlCol="0" anchor="ctr"/>
           <a:lstStyle/>
           <a:p>
             <a:pPr algn="ctr">
@@ -13642,7 +13580,7 @@
           </a:fontRef>
         </p:style>
         <p:txBody>
-          <a:bodyPr rtlCol="0" anchor="ctr" wrap="square"/>
+          <a:bodyPr wrap="square" rtlCol="0" anchor="ctr"/>
           <a:lstStyle/>
           <a:p>
             <a:pPr algn="ctr">
@@ -13681,7 +13619,7 @@
           <p:nvPr/>
         </p:nvPicPr>
         <p:blipFill>
-          <a:blip r:embed="rId4"/>
+          <a:blip r:embed="rId3"/>
           <a:stretch>
             <a:fillRect/>
           </a:stretch>
@@ -13780,7 +13718,7 @@
 </file>
 
 <file path=ppt/slides/slide9.xml><?xml version="1.0" encoding="utf-8"?>
-<p:sld xmlns:a="http://schemas.openxmlformats.org/drawingml/2006/main" xmlns:p="http://schemas.openxmlformats.org/presentationml/2006/main" xmlns:r="http://schemas.openxmlformats.org/officeDocument/2006/relationships">
+<p:sld xmlns:a="http://schemas.openxmlformats.org/drawingml/2006/main" xmlns:r="http://schemas.openxmlformats.org/officeDocument/2006/relationships" xmlns:p="http://schemas.openxmlformats.org/presentationml/2006/main">
   <p:cSld>
     <p:bg>
       <p:bgPr>
@@ -13796,7 +13734,14 @@
         <p:cNvGrpSpPr/>
         <p:nvPr/>
       </p:nvGrpSpPr>
-      <p:grpSpPr/>
+      <p:grpSpPr>
+        <a:xfrm>
+          <a:off x="0" y="0"/>
+          <a:ext cx="0" cy="0"/>
+          <a:chOff x="0" y="0"/>
+          <a:chExt cx="0" cy="0"/>
+        </a:xfrm>
+      </p:grpSpPr>
       <p:sp>
         <p:nvSpPr>
           <p:cNvPr id="2" name="Rectangle 1"/>
@@ -13837,6 +13782,7 @@
           <a:lstStyle/>
           <a:p>
             <a:pPr algn="ctr"/>
+            <a:endParaRPr/>
           </a:p>
         </p:txBody>
       </p:sp>
@@ -14153,7 +14099,7 @@
           </a:fontRef>
         </p:style>
         <p:txBody>
-          <a:bodyPr rtlCol="0" anchor="ctr" wrap="square"/>
+          <a:bodyPr wrap="square" rtlCol="0" anchor="ctr"/>
           <a:lstStyle/>
           <a:p>
             <a:pPr algn="l">
@@ -14566,7 +14512,7 @@
 </file>
 
 <file path=ppt/theme/theme2.xml><?xml version="1.0" encoding="utf-8"?>
-<a:theme xmlns:a="http://schemas.openxmlformats.org/drawingml/2006/main" name="Office Theme">
+<a:theme xmlns:a="http://schemas.openxmlformats.org/drawingml/2006/main" name="Office 主题​​">
   <a:themeElements>
     <a:clrScheme name="Office">
       <a:dk1>
@@ -14576,44 +14522,44 @@
         <a:sysClr val="window" lastClr="FFFFFF"/>
       </a:lt1>
       <a:dk2>
-        <a:srgbClr val="1F497D"/>
+        <a:srgbClr val="44546A"/>
       </a:dk2>
       <a:lt2>
-        <a:srgbClr val="EEECE1"/>
+        <a:srgbClr val="E7E6E6"/>
       </a:lt2>
       <a:accent1>
-        <a:srgbClr val="4F81BD"/>
+        <a:srgbClr val="4472C4"/>
       </a:accent1>
       <a:accent2>
-        <a:srgbClr val="C0504D"/>
+        <a:srgbClr val="ED7D31"/>
       </a:accent2>
       <a:accent3>
-        <a:srgbClr val="9BBB59"/>
+        <a:srgbClr val="A5A5A5"/>
       </a:accent3>
       <a:accent4>
-        <a:srgbClr val="8064A2"/>
+        <a:srgbClr val="FFC000"/>
       </a:accent4>
       <a:accent5>
-        <a:srgbClr val="4BACC6"/>
+        <a:srgbClr val="5B9BD5"/>
       </a:accent5>
       <a:accent6>
-        <a:srgbClr val="F79646"/>
+        <a:srgbClr val="70AD47"/>
       </a:accent6>
       <a:hlink>
-        <a:srgbClr val="0000FF"/>
+        <a:srgbClr val="0563C1"/>
       </a:hlink>
       <a:folHlink>
-        <a:srgbClr val="800080"/>
+        <a:srgbClr val="954F72"/>
       </a:folHlink>
     </a:clrScheme>
     <a:fontScheme name="Office">
       <a:majorFont>
-        <a:latin typeface="Calibri"/>
+        <a:latin typeface="等线 Light" panose="020F0302020204030204"/>
         <a:ea typeface=""/>
         <a:cs typeface=""/>
-        <a:font script="Jpan" typeface="ＭＳ Ｐゴシック"/>
+        <a:font script="Jpan" typeface="游ゴシック Light"/>
         <a:font script="Hang" typeface="맑은 고딕"/>
-        <a:font script="Hans" typeface="宋体"/>
+        <a:font script="Hans" typeface="等线 Light"/>
         <a:font script="Hant" typeface="新細明體"/>
         <a:font script="Arab" typeface="Times New Roman"/>
         <a:font script="Hebr" typeface="Times New Roman"/>
@@ -14641,14 +14587,31 @@
         <a:font script="Viet" typeface="Times New Roman"/>
         <a:font script="Uigh" typeface="Microsoft Uighur"/>
         <a:font script="Geor" typeface="Sylfaen"/>
+        <a:font script="Armn" typeface="Arial"/>
+        <a:font script="Bugi" typeface="Leelawadee UI"/>
+        <a:font script="Bopo" typeface="Microsoft JhengHei"/>
+        <a:font script="Java" typeface="Javanese Text"/>
+        <a:font script="Lisu" typeface="Segoe UI"/>
+        <a:font script="Mymr" typeface="Myanmar Text"/>
+        <a:font script="Nkoo" typeface="Ebrima"/>
+        <a:font script="Olck" typeface="Nirmala UI"/>
+        <a:font script="Osma" typeface="Ebrima"/>
+        <a:font script="Phag" typeface="Phagspa"/>
+        <a:font script="Syrn" typeface="Estrangelo Edessa"/>
+        <a:font script="Syrj" typeface="Estrangelo Edessa"/>
+        <a:font script="Syre" typeface="Estrangelo Edessa"/>
+        <a:font script="Sora" typeface="Nirmala UI"/>
+        <a:font script="Tale" typeface="Microsoft Tai Le"/>
+        <a:font script="Talu" typeface="Microsoft New Tai Lue"/>
+        <a:font script="Tfng" typeface="Ebrima"/>
       </a:majorFont>
       <a:minorFont>
-        <a:latin typeface="Calibri"/>
+        <a:latin typeface="等线" panose="020F0502020204030204"/>
         <a:ea typeface=""/>
         <a:cs typeface=""/>
-        <a:font script="Jpan" typeface="ＭＳ Ｐゴシック"/>
+        <a:font script="Jpan" typeface="游ゴシック"/>
         <a:font script="Hang" typeface="맑은 고딕"/>
-        <a:font script="Hans" typeface="宋体"/>
+        <a:font script="Hans" typeface="等线"/>
         <a:font script="Hant" typeface="新細明體"/>
         <a:font script="Arab" typeface="Arial"/>
         <a:font script="Hebr" typeface="Arial"/>
@@ -14676,6 +14639,23 @@
         <a:font script="Viet" typeface="Arial"/>
         <a:font script="Uigh" typeface="Microsoft Uighur"/>
         <a:font script="Geor" typeface="Sylfaen"/>
+        <a:font script="Armn" typeface="Arial"/>
+        <a:font script="Bugi" typeface="Leelawadee UI"/>
+        <a:font script="Bopo" typeface="Microsoft JhengHei"/>
+        <a:font script="Java" typeface="Javanese Text"/>
+        <a:font script="Lisu" typeface="Segoe UI"/>
+        <a:font script="Mymr" typeface="Myanmar Text"/>
+        <a:font script="Nkoo" typeface="Ebrima"/>
+        <a:font script="Olck" typeface="Nirmala UI"/>
+        <a:font script="Osma" typeface="Ebrima"/>
+        <a:font script="Phag" typeface="Phagspa"/>
+        <a:font script="Syrn" typeface="Estrangelo Edessa"/>
+        <a:font script="Syrj" typeface="Estrangelo Edessa"/>
+        <a:font script="Syre" typeface="Estrangelo Edessa"/>
+        <a:font script="Sora" typeface="Nirmala UI"/>
+        <a:font script="Tale" typeface="Microsoft Tai Le"/>
+        <a:font script="Talu" typeface="Microsoft New Tai Lue"/>
+        <a:font script="Tfng" typeface="Ebrima"/>
       </a:minorFont>
     </a:fontScheme>
     <a:fmtScheme name="Office">
@@ -14687,200 +14667,141 @@
           <a:gsLst>
             <a:gs pos="0">
               <a:schemeClr val="phClr">
-                <a:tint val="50000"/>
-                <a:satMod val="300000"/>
+                <a:lumMod val="110000"/>
+                <a:satMod val="105000"/>
+                <a:tint val="67000"/>
               </a:schemeClr>
             </a:gs>
-            <a:gs pos="35000">
+            <a:gs pos="50000">
               <a:schemeClr val="phClr">
-                <a:tint val="37000"/>
-                <a:satMod val="300000"/>
+                <a:lumMod val="105000"/>
+                <a:satMod val="103000"/>
+                <a:tint val="73000"/>
               </a:schemeClr>
             </a:gs>
             <a:gs pos="100000">
               <a:schemeClr val="phClr">
-                <a:tint val="15000"/>
-                <a:satMod val="350000"/>
+                <a:lumMod val="105000"/>
+                <a:satMod val="109000"/>
+                <a:tint val="81000"/>
               </a:schemeClr>
             </a:gs>
           </a:gsLst>
-          <a:lin ang="16200000" scaled="1"/>
+          <a:lin ang="5400000" scaled="0"/>
         </a:gradFill>
         <a:gradFill rotWithShape="1">
           <a:gsLst>
             <a:gs pos="0">
               <a:schemeClr val="phClr">
-                <a:tint val="100000"/>
+                <a:satMod val="103000"/>
+                <a:lumMod val="102000"/>
+                <a:tint val="94000"/>
+              </a:schemeClr>
+            </a:gs>
+            <a:gs pos="50000">
+              <a:schemeClr val="phClr">
+                <a:satMod val="110000"/>
+                <a:lumMod val="100000"/>
                 <a:shade val="100000"/>
-                <a:satMod val="130000"/>
               </a:schemeClr>
             </a:gs>
             <a:gs pos="100000">
               <a:schemeClr val="phClr">
-                <a:tint val="50000"/>
-                <a:shade val="100000"/>
-                <a:satMod val="350000"/>
+                <a:lumMod val="99000"/>
+                <a:satMod val="120000"/>
+                <a:shade val="78000"/>
               </a:schemeClr>
             </a:gs>
           </a:gsLst>
-          <a:lin ang="16200000" scaled="0"/>
+          <a:lin ang="5400000" scaled="0"/>
         </a:gradFill>
       </a:fillStyleLst>
       <a:lnStyleLst>
-        <a:ln w="9525" cap="flat" cmpd="sng" algn="ctr">
-          <a:solidFill>
-            <a:schemeClr val="phClr">
-              <a:shade val="95000"/>
-              <a:satMod val="105000"/>
-            </a:schemeClr>
-          </a:solidFill>
-          <a:prstDash val="solid"/>
-        </a:ln>
-        <a:ln w="25400" cap="flat" cmpd="sng" algn="ctr">
+        <a:ln w="6350" cap="flat" cmpd="sng" algn="ctr">
           <a:solidFill>
             <a:schemeClr val="phClr"/>
           </a:solidFill>
           <a:prstDash val="solid"/>
+          <a:miter lim="800000"/>
         </a:ln>
-        <a:ln w="38100" cap="flat" cmpd="sng" algn="ctr">
+        <a:ln w="12700" cap="flat" cmpd="sng" algn="ctr">
           <a:solidFill>
             <a:schemeClr val="phClr"/>
           </a:solidFill>
           <a:prstDash val="solid"/>
+          <a:miter lim="800000"/>
+        </a:ln>
+        <a:ln w="19050" cap="flat" cmpd="sng" algn="ctr">
+          <a:solidFill>
+            <a:schemeClr val="phClr"/>
+          </a:solidFill>
+          <a:prstDash val="solid"/>
+          <a:miter lim="800000"/>
         </a:ln>
       </a:lnStyleLst>
       <a:effectStyleLst>
         <a:effectStyle>
+          <a:effectLst/>
+        </a:effectStyle>
+        <a:effectStyle>
+          <a:effectLst/>
+        </a:effectStyle>
+        <a:effectStyle>
           <a:effectLst>
-            <a:outerShdw blurRad="40000" dist="20000" dir="5400000" rotWithShape="0">
+            <a:outerShdw blurRad="57150" dist="19050" dir="5400000" algn="ctr" rotWithShape="0">
               <a:srgbClr val="000000">
-                <a:alpha val="38000"/>
+                <a:alpha val="63000"/>
               </a:srgbClr>
             </a:outerShdw>
           </a:effectLst>
-        </a:effectStyle>
-        <a:effectStyle>
-          <a:effectLst>
-            <a:outerShdw blurRad="40000" dist="23000" dir="5400000" rotWithShape="0">
-              <a:srgbClr val="000000">
-                <a:alpha val="35000"/>
-              </a:srgbClr>
-            </a:outerShdw>
-          </a:effectLst>
-        </a:effectStyle>
-        <a:effectStyle>
-          <a:effectLst>
-            <a:outerShdw blurRad="40000" dist="23000" dir="5400000" rotWithShape="0">
-              <a:srgbClr val="000000">
-                <a:alpha val="35000"/>
-              </a:srgbClr>
-            </a:outerShdw>
-          </a:effectLst>
-          <a:scene3d>
-            <a:camera prst="orthographicFront">
-              <a:rot lat="0" lon="0" rev="0"/>
-            </a:camera>
-            <a:lightRig rig="threePt" dir="t">
-              <a:rot lat="0" lon="0" rev="1200000"/>
-            </a:lightRig>
-          </a:scene3d>
-          <a:sp3d>
-            <a:bevelT w="63500" h="25400"/>
-          </a:sp3d>
         </a:effectStyle>
       </a:effectStyleLst>
       <a:bgFillStyleLst>
         <a:solidFill>
           <a:schemeClr val="phClr"/>
         </a:solidFill>
+        <a:solidFill>
+          <a:schemeClr val="phClr">
+            <a:tint val="95000"/>
+            <a:satMod val="170000"/>
+          </a:schemeClr>
+        </a:solidFill>
         <a:gradFill rotWithShape="1">
           <a:gsLst>
             <a:gs pos="0">
               <a:schemeClr val="phClr">
-                <a:tint val="40000"/>
-                <a:satMod val="350000"/>
+                <a:tint val="93000"/>
+                <a:satMod val="150000"/>
+                <a:shade val="98000"/>
+                <a:lumMod val="102000"/>
               </a:schemeClr>
             </a:gs>
-            <a:gs pos="40000">
+            <a:gs pos="50000">
               <a:schemeClr val="phClr">
-                <a:tint val="45000"/>
-                <a:shade val="99000"/>
-                <a:satMod val="350000"/>
+                <a:tint val="98000"/>
+                <a:satMod val="130000"/>
+                <a:shade val="90000"/>
+                <a:lumMod val="103000"/>
               </a:schemeClr>
             </a:gs>
             <a:gs pos="100000">
               <a:schemeClr val="phClr">
-                <a:shade val="20000"/>
-                <a:satMod val="255000"/>
+                <a:shade val="63000"/>
+                <a:satMod val="120000"/>
               </a:schemeClr>
             </a:gs>
           </a:gsLst>
-          <a:path path="circle">
-            <a:fillToRect l="50000" t="-80000" r="50000" b="180000"/>
-          </a:path>
-        </a:gradFill>
-        <a:gradFill rotWithShape="1">
-          <a:gsLst>
-            <a:gs pos="0">
-              <a:schemeClr val="phClr">
-                <a:tint val="80000"/>
-                <a:satMod val="300000"/>
-              </a:schemeClr>
-            </a:gs>
-            <a:gs pos="100000">
-              <a:schemeClr val="phClr">
-                <a:shade val="30000"/>
-                <a:satMod val="200000"/>
-              </a:schemeClr>
-            </a:gs>
-          </a:gsLst>
-          <a:path path="circle">
-            <a:fillToRect l="50000" t="50000" r="50000" b="50000"/>
-          </a:path>
+          <a:lin ang="5400000" scaled="0"/>
         </a:gradFill>
       </a:bgFillStyleLst>
     </a:fmtScheme>
   </a:themeElements>
-  <a:objectDefaults>
-    <a:spDef>
-      <a:spPr/>
-      <a:bodyPr/>
-      <a:lstStyle/>
-      <a:style>
-        <a:lnRef idx="1">
-          <a:schemeClr val="accent1"/>
-        </a:lnRef>
-        <a:fillRef idx="3">
-          <a:schemeClr val="accent1"/>
-        </a:fillRef>
-        <a:effectRef idx="2">
-          <a:schemeClr val="accent1"/>
-        </a:effectRef>
-        <a:fontRef idx="minor">
-          <a:schemeClr val="lt1"/>
-        </a:fontRef>
-      </a:style>
-    </a:spDef>
-    <a:lnDef>
-      <a:spPr/>
-      <a:bodyPr/>
-      <a:lstStyle/>
-      <a:style>
-        <a:lnRef idx="2">
-          <a:schemeClr val="accent1"/>
-        </a:lnRef>
-        <a:fillRef idx="0">
-          <a:schemeClr val="accent1"/>
-        </a:fillRef>
-        <a:effectRef idx="1">
-          <a:schemeClr val="accent1"/>
-        </a:effectRef>
-        <a:fontRef idx="minor">
-          <a:schemeClr val="tx1"/>
-        </a:fontRef>
-      </a:style>
-    </a:lnDef>
-  </a:objectDefaults>
+  <a:objectDefaults/>
   <a:extraClrSchemeLst/>
+  <a:extLst>
+    <a:ext uri="{05A4C25C-085E-4340-85A3-A5531E510DB2}">
+      <thm15:themeFamily xmlns:thm15="http://schemas.microsoft.com/office/thememl/2012/main" name="Office Theme" id="{62F939B6-93AF-4DB8-9C6B-D6C7DFDC589F}" vid="{4A3C46E8-61CC-4603-A589-7422A47A8E4A}"/>
+    </a:ext>
+  </a:extLst>
 </a:theme>
 </file>
</xml_diff>